<commit_message>
readiness brief Part B: each body's public data interface (page four and its slide)
reports/diagnostic/brief/api_terms.yaml: 19 rows (16 bodies, 3 reference hosts), every term
with a .gov URL and verbatim passage, 'not stated', or 'not determined' where the agency's own
site refused the fetch (BTS, ORES: HTTP 403). Desk research by WebSearch + WebFetch to .gov
hosts only; labelled as such in the brief. scripts/api_terms_check.py assembles, checks
(exits non-zero on an unsourced term; BLS must state both API versions) and tabulates.
Brief rebuilt: docx 4 pages, pptx 7 slides, all checks pass. DataFile be5253bc.

Co-Authored-By: Claude Opus 5.5 <noreply@anthropic.com>
</commit_message>
<xml_diff>
--- a/reports/diagnostic/brief/READINESS_BRIEF.pptx
+++ b/reports/diagnostic/brief/READINESS_BRIEF.pptx
@@ -8739,8 +8739,8 @@
         </p:nvSpPr>
         <p:spPr>
           <a:xfrm>
-            <a:off x="548640" y="2560320"/>
-            <a:ext cx="11064240" cy="5303520"/>
+            <a:off x="548640" y="731520"/>
+            <a:ext cx="11064240" cy="320040"/>
           </a:xfrm>
           <a:prstGeom prst="rect">
             <a:avLst/>
@@ -8754,17 +8754,2727 @@
           <a:lstStyle/>
           <a:p>
             <a:r>
-              <a:rPr b="0" sz="1800">
+              <a:rPr b="0" sz="1100">
                 <a:solidFill>
-                  <a:srgbClr val="000000"/>
+                  <a:srgbClr val="555555"/>
                 </a:solidFill>
                 <a:latin typeface="Calibri"/>
               </a:rPr>
-              <a:t>The table of each body's public data interface follows next week.</a:t>
+              <a:t>Confirmed from each agency's own pages on 16 October 2026; desk research, not a measured check.</a:t>
             </a:r>
           </a:p>
         </p:txBody>
       </p:sp>
+      <p:graphicFrame>
+        <p:nvGraphicFramePr>
+          <p:cNvPr id="4" name="Table 3"/>
+          <p:cNvGraphicFramePr>
+            <a:graphicFrameLocks noGrp="1"/>
+          </p:cNvGraphicFramePr>
+          <p:nvPr/>
+        </p:nvGraphicFramePr>
+        <p:xfrm>
+          <a:off x="365760" y="1051560"/>
+          <a:ext cx="11430000" cy="2194560"/>
+        </p:xfrm>
+        <a:graphic>
+          <a:graphicData uri="http://schemas.openxmlformats.org/drawingml/2006/table">
+            <a:tbl>
+              <a:tblPr>
+                <a:tableStyleId>{5C22544A-7EE6-4342-B048-85BDC9FD1C3A}</a:tableStyleId>
+              </a:tblPr>
+              <a:tblGrid>
+                <a:gridCol w="822960"/>
+                <a:gridCol w="2286000"/>
+                <a:gridCol w="2103120"/>
+                <a:gridCol w="2377440"/>
+                <a:gridCol w="2103120"/>
+                <a:gridCol w="1737360"/>
+              </a:tblGrid>
+              <a:tr h="109728">
+                <a:tc>
+                  <a:txBody>
+                    <a:bodyPr wrap="square"/>
+                    <a:lstStyle/>
+                    <a:p>
+                      <a:r>
+                        <a:rPr b="1" sz="600">
+                          <a:solidFill>
+                            <a:srgbClr val="C25600"/>
+                          </a:solidFill>
+                          <a:latin typeface="Calibri"/>
+                        </a:rPr>
+                        <a:t>Body</a:t>
+                      </a:r>
+                    </a:p>
+                  </a:txBody>
+                  <a:tcPr marT="9144" marB="9144">
+                    <a:solidFill>
+                      <a:srgbClr val="FFFFFF"/>
+                    </a:solidFill>
+                  </a:tcPr>
+                </a:tc>
+                <a:tc>
+                  <a:txBody>
+                    <a:bodyPr wrap="square"/>
+                    <a:lstStyle/>
+                    <a:p>
+                      <a:r>
+                        <a:rPr b="1" sz="600">
+                          <a:solidFill>
+                            <a:srgbClr val="C25600"/>
+                          </a:solidFill>
+                          <a:latin typeface="Calibri"/>
+                        </a:rPr>
+                        <a:t>API</a:t>
+                      </a:r>
+                    </a:p>
+                  </a:txBody>
+                  <a:tcPr marT="9144" marB="9144">
+                    <a:solidFill>
+                      <a:srgbClr val="FFFFFF"/>
+                    </a:solidFill>
+                  </a:tcPr>
+                </a:tc>
+                <a:tc>
+                  <a:txBody>
+                    <a:bodyPr wrap="square"/>
+                    <a:lstStyle/>
+                    <a:p>
+                      <a:r>
+                        <a:rPr b="1" sz="600">
+                          <a:solidFill>
+                            <a:srgbClr val="C25600"/>
+                          </a:solidFill>
+                          <a:latin typeface="Calibri"/>
+                        </a:rPr>
+                        <a:t>How a machine calls it</a:t>
+                      </a:r>
+                    </a:p>
+                  </a:txBody>
+                  <a:tcPr marT="9144" marB="9144">
+                    <a:solidFill>
+                      <a:srgbClr val="FFFFFF"/>
+                    </a:solidFill>
+                  </a:tcPr>
+                </a:tc>
+                <a:tc>
+                  <a:txBody>
+                    <a:bodyPr wrap="square"/>
+                    <a:lstStyle/>
+                    <a:p>
+                      <a:r>
+                        <a:rPr b="1" sz="600">
+                          <a:solidFill>
+                            <a:srgbClr val="C25600"/>
+                          </a:solidFill>
+                          <a:latin typeface="Calibri"/>
+                        </a:rPr>
+                        <a:t>How a key is obtained</a:t>
+                      </a:r>
+                    </a:p>
+                  </a:txBody>
+                  <a:tcPr marT="9144" marB="9144">
+                    <a:solidFill>
+                      <a:srgbClr val="FFFFFF"/>
+                    </a:solidFill>
+                  </a:tcPr>
+                </a:tc>
+                <a:tc>
+                  <a:txBody>
+                    <a:bodyPr wrap="square"/>
+                    <a:lstStyle/>
+                    <a:p>
+                      <a:r>
+                        <a:rPr b="1" sz="600">
+                          <a:solidFill>
+                            <a:srgbClr val="C25600"/>
+                          </a:solidFill>
+                          <a:latin typeface="Calibri"/>
+                        </a:rPr>
+                        <a:t>What a key changes</a:t>
+                      </a:r>
+                    </a:p>
+                  </a:txBody>
+                  <a:tcPr marT="9144" marB="9144">
+                    <a:solidFill>
+                      <a:srgbClr val="FFFFFF"/>
+                    </a:solidFill>
+                  </a:tcPr>
+                </a:tc>
+                <a:tc>
+                  <a:txBody>
+                    <a:bodyPr wrap="square"/>
+                    <a:lstStyle/>
+                    <a:p>
+                      <a:r>
+                        <a:rPr b="1" sz="600">
+                          <a:solidFill>
+                            <a:srgbClr val="C25600"/>
+                          </a:solidFill>
+                          <a:latin typeface="Calibri"/>
+                        </a:rPr>
+                        <a:t>Announced to machines: developer page / data.json / api-catalog / data page link</a:t>
+                      </a:r>
+                    </a:p>
+                  </a:txBody>
+                  <a:tcPr marT="9144" marB="9144">
+                    <a:solidFill>
+                      <a:srgbClr val="FFFFFF"/>
+                    </a:solidFill>
+                  </a:tcPr>
+                </a:tc>
+              </a:tr>
+              <a:tr h="109728">
+                <a:tc>
+                  <a:txBody>
+                    <a:bodyPr wrap="square"/>
+                    <a:lstStyle/>
+                    <a:p>
+                      <a:r>
+                        <a:rPr b="0" sz="500">
+                          <a:solidFill>
+                            <a:srgbClr val="000000"/>
+                          </a:solidFill>
+                          <a:latin typeface="Calibri"/>
+                        </a:rPr>
+                        <a:t>BEA</a:t>
+                      </a:r>
+                    </a:p>
+                  </a:txBody>
+                  <a:tcPr marT="9144" marB="9144">
+                    <a:solidFill>
+                      <a:srgbClr val="FFFFFF"/>
+                    </a:solidFill>
+                  </a:tcPr>
+                </a:tc>
+                <a:tc>
+                  <a:txBody>
+                    <a:bodyPr wrap="square"/>
+                    <a:lstStyle/>
+                    <a:p>
+                      <a:r>
+                        <a:rPr b="0" sz="500">
+                          <a:solidFill>
+                            <a:srgbClr val="000000"/>
+                          </a:solidFill>
+                          <a:latin typeface="Calibri"/>
+                        </a:rPr>
+                        <a:t>BEA Data Retrieval API, single base https://apps.bea.gov/api/data</a:t>
+                      </a:r>
+                    </a:p>
+                  </a:txBody>
+                  <a:tcPr marT="9144" marB="9144">
+                    <a:solidFill>
+                      <a:srgbClr val="FFFFFF"/>
+                    </a:solidFill>
+                  </a:tcPr>
+                </a:tc>
+                <a:tc>
+                  <a:txBody>
+                    <a:bodyPr wrap="square"/>
+                    <a:lstStyle/>
+                    <a:p>
+                      <a:r>
+                        <a:rPr b="0" sz="500">
+                          <a:solidFill>
+                            <a:srgbClr val="000000"/>
+                          </a:solidFill>
+                          <a:latin typeface="Calibri"/>
+                        </a:rPr>
+                        <a:t>Key (36-character UserID) required in the query string on every request; limits per user of 100 requests, 100 MB and 30 errors per minute, HTTP 429 when exceeded.</a:t>
+                      </a:r>
+                    </a:p>
+                  </a:txBody>
+                  <a:tcPr marT="9144" marB="9144">
+                    <a:solidFill>
+                      <a:srgbClr val="FFFFFF"/>
+                    </a:solidFill>
+                  </a:tcPr>
+                </a:tc>
+                <a:tc>
+                  <a:txBody>
+                    <a:bodyPr wrap="square"/>
+                    <a:lstStyle/>
+                    <a:p>
+                      <a:r>
+                        <a:rPr b="0" sz="500">
+                          <a:solidFill>
+                            <a:srgbClr val="000000"/>
+                          </a:solidFill>
+                          <a:latin typeface="Calibri"/>
+                        </a:rPr>
+                        <a:t>Name or organization name, a valid non-disposable email, and agreeing to terms of service; a person must click the emailed link before the UserID is activated.</a:t>
+                      </a:r>
+                    </a:p>
+                  </a:txBody>
+                  <a:tcPr marT="9144" marB="9144">
+                    <a:solidFill>
+                      <a:srgbClr val="FFFFFF"/>
+                    </a:solidFill>
+                  </a:tcPr>
+                </a:tc>
+                <a:tc>
+                  <a:txBody>
+                    <a:bodyPr wrap="square"/>
+                    <a:lstStyle/>
+                    <a:p>
+                      <a:r>
+                        <a:rPr b="0" sz="500">
+                          <a:solidFill>
+                            <a:srgbClr val="000000"/>
+                          </a:solidFill>
+                          <a:latin typeface="Calibri"/>
+                        </a:rPr>
+                        <a:t>There is no keyless tier; the key is the only way to use the API at all.</a:t>
+                      </a:r>
+                    </a:p>
+                  </a:txBody>
+                  <a:tcPr marT="9144" marB="9144">
+                    <a:solidFill>
+                      <a:srgbClr val="FFFFFF"/>
+                    </a:solidFill>
+                  </a:tcPr>
+                </a:tc>
+                <a:tc>
+                  <a:txBody>
+                    <a:bodyPr wrap="square"/>
+                    <a:lstStyle/>
+                    <a:p>
+                      <a:r>
+                        <a:rPr b="0" sz="500">
+                          <a:solidFill>
+                            <a:srgbClr val="000000"/>
+                          </a:solidFill>
+                          <a:latin typeface="Calibri"/>
+                        </a:rPr>
+                        <a:t>yes / yes / no / yes</a:t>
+                      </a:r>
+                    </a:p>
+                  </a:txBody>
+                  <a:tcPr marT="9144" marB="9144">
+                    <a:solidFill>
+                      <a:srgbClr val="FFFFFF"/>
+                    </a:solidFill>
+                  </a:tcPr>
+                </a:tc>
+              </a:tr>
+              <a:tr h="109728">
+                <a:tc>
+                  <a:txBody>
+                    <a:bodyPr wrap="square"/>
+                    <a:lstStyle/>
+                    <a:p>
+                      <a:r>
+                        <a:rPr b="0" sz="500">
+                          <a:solidFill>
+                            <a:srgbClr val="000000"/>
+                          </a:solidFill>
+                          <a:latin typeface="Calibri"/>
+                        </a:rPr>
+                        <a:t>BJS</a:t>
+                      </a:r>
+                    </a:p>
+                  </a:txBody>
+                  <a:tcPr marT="9144" marB="9144">
+                    <a:solidFill>
+                      <a:srgbClr val="FFFFFF"/>
+                    </a:solidFill>
+                  </a:tcPr>
+                </a:tc>
+                <a:tc>
+                  <a:txBody>
+                    <a:bodyPr wrap="square"/>
+                    <a:lstStyle/>
+                    <a:p>
+                      <a:r>
+                        <a:rPr b="0" sz="500">
+                          <a:solidFill>
+                            <a:srgbClr val="000000"/>
+                          </a:solidFill>
+                          <a:latin typeface="Calibri"/>
+                        </a:rPr>
+                        <a:t>NCVS API (also a NIBRS National Estimates API), base https://api.ojp.gov/bjsdataset/v1/; formerly https://data.ojp.usdoj.gov/resource/ on Socrata SODA</a:t>
+                      </a:r>
+                    </a:p>
+                  </a:txBody>
+                  <a:tcPr marT="9144" marB="9144">
+                    <a:solidFill>
+                      <a:srgbClr val="FFFFFF"/>
+                    </a:solidFill>
+                  </a:tcPr>
+                </a:tc>
+                <a:tc>
+                  <a:txBody>
+                    <a:bodyPr wrap="square"/>
+                    <a:lstStyle/>
+                    <a:p>
+                      <a:r>
+                        <a:rPr b="0" sz="500">
+                          <a:solidFill>
+                            <a:srgbClr val="000000"/>
+                          </a:solidFill>
+                          <a:latin typeface="Calibri"/>
+                        </a:rPr>
+                        <a:t>no key stated: a query is endpoint plus format plus parameters; default cap of 1,000 records, raised with a Limit parameter</a:t>
+                      </a:r>
+                    </a:p>
+                  </a:txBody>
+                  <a:tcPr marT="9144" marB="9144">
+                    <a:solidFill>
+                      <a:srgbClr val="FFFFFF"/>
+                    </a:solidFill>
+                  </a:tcPr>
+                </a:tc>
+                <a:tc>
+                  <a:txBody>
+                    <a:bodyPr wrap="square"/>
+                    <a:lstStyle/>
+                    <a:p>
+                      <a:r>
+                        <a:rPr b="0" sz="500">
+                          <a:solidFill>
+                            <a:srgbClr val="000000"/>
+                          </a:solidFill>
+                          <a:latin typeface="Calibri"/>
+                        </a:rPr>
+                        <a:t>not stated</a:t>
+                      </a:r>
+                    </a:p>
+                  </a:txBody>
+                  <a:tcPr marT="9144" marB="9144">
+                    <a:solidFill>
+                      <a:srgbClr val="FFFFFF"/>
+                    </a:solidFill>
+                  </a:tcPr>
+                </a:tc>
+                <a:tc>
+                  <a:txBody>
+                    <a:bodyPr wrap="square"/>
+                    <a:lstStyle/>
+                    <a:p>
+                      <a:r>
+                        <a:rPr b="0" sz="500">
+                          <a:solidFill>
+                            <a:srgbClr val="000000"/>
+                          </a:solidFill>
+                          <a:latin typeface="Calibri"/>
+                        </a:rPr>
+                        <a:t>not stated</a:t>
+                      </a:r>
+                    </a:p>
+                  </a:txBody>
+                  <a:tcPr marT="9144" marB="9144">
+                    <a:solidFill>
+                      <a:srgbClr val="FFFFFF"/>
+                    </a:solidFill>
+                  </a:tcPr>
+                </a:tc>
+                <a:tc>
+                  <a:txBody>
+                    <a:bodyPr wrap="square"/>
+                    <a:lstStyle/>
+                    <a:p>
+                      <a:r>
+                        <a:rPr b="0" sz="500">
+                          <a:solidFill>
+                            <a:srgbClr val="000000"/>
+                          </a:solidFill>
+                          <a:latin typeface="Calibri"/>
+                        </a:rPr>
+                        <a:t>no / not determined / no / no</a:t>
+                      </a:r>
+                    </a:p>
+                  </a:txBody>
+                  <a:tcPr marT="9144" marB="9144">
+                    <a:solidFill>
+                      <a:srgbClr val="FFFFFF"/>
+                    </a:solidFill>
+                  </a:tcPr>
+                </a:tc>
+              </a:tr>
+              <a:tr h="109728">
+                <a:tc>
+                  <a:txBody>
+                    <a:bodyPr wrap="square"/>
+                    <a:lstStyle/>
+                    <a:p>
+                      <a:r>
+                        <a:rPr b="0" sz="500">
+                          <a:solidFill>
+                            <a:srgbClr val="000000"/>
+                          </a:solidFill>
+                          <a:latin typeface="Calibri"/>
+                        </a:rPr>
+                        <a:t>BLS</a:t>
+                      </a:r>
+                    </a:p>
+                  </a:txBody>
+                  <a:tcPr marT="9144" marB="9144">
+                    <a:solidFill>
+                      <a:srgbClr val="FFFFFF"/>
+                    </a:solidFill>
+                  </a:tcPr>
+                </a:tc>
+                <a:tc>
+                  <a:txBody>
+                    <a:bodyPr wrap="square"/>
+                    <a:lstStyle/>
+                    <a:p>
+                      <a:r>
+                        <a:rPr b="0" sz="500">
+                          <a:solidFill>
+                            <a:srgbClr val="000000"/>
+                          </a:solidFill>
+                          <a:latin typeface="Calibri"/>
+                        </a:rPr>
+                        <a:t>BLS Public Data API, versions 1.0 and 2.0; v2 base https://api.bls.gov/publicAPI/v2/ (timeseries/data/, timeseries/popular, surveys)</a:t>
+                      </a:r>
+                    </a:p>
+                  </a:txBody>
+                  <a:tcPr marT="9144" marB="9144">
+                    <a:solidFill>
+                      <a:srgbClr val="FFFFFF"/>
+                    </a:solidFill>
+                  </a:tcPr>
+                </a:tc>
+                <a:tc>
+                  <a:txBody>
+                    <a:bodyPr wrap="square"/>
+                    <a:lstStyle/>
+                    <a:p>
+                      <a:r>
+                        <a:rPr b="0" sz="500">
+                          <a:solidFill>
+                            <a:srgbClr val="000000"/>
+                          </a:solidFill>
+                          <a:latin typeface="Calibri"/>
+                        </a:rPr>
+                        <a:t>Version 1.0: no key, 25 queries daily, 25 series and 10 years per query. Version 2.0: registration key required in requests, 500 queries daily, 50 series, 20 years.</a:t>
+                      </a:r>
+                    </a:p>
+                  </a:txBody>
+                  <a:tcPr marT="9144" marB="9144">
+                    <a:solidFill>
+                      <a:srgbClr val="FFFFFF"/>
+                    </a:solidFill>
+                  </a:tcPr>
+                </a:tc>
+                <a:tc>
+                  <a:txBody>
+                    <a:bodyPr wrap="square"/>
+                    <a:lstStyle/>
+                    <a:p>
+                      <a:r>
+                        <a:rPr b="0" sz="500">
+                          <a:solidFill>
+                            <a:srgbClr val="000000"/>
+                          </a:solidFill>
+                          <a:latin typeface="Calibri"/>
+                        </a:rPr>
+                        <a:t>Registration form asks organization name and email, a CAPTCHA, and agreeing to Terms of Service; the key arrives by email, so a person must open that email. No activation link stated.</a:t>
+                      </a:r>
+                    </a:p>
+                  </a:txBody>
+                  <a:tcPr marT="9144" marB="9144">
+                    <a:solidFill>
+                      <a:srgbClr val="FFFFFF"/>
+                    </a:solidFill>
+                  </a:tcPr>
+                </a:tc>
+                <a:tc>
+                  <a:txBody>
+                    <a:bodyPr wrap="square"/>
+                    <a:lstStyle/>
+                    <a:p>
+                      <a:r>
+                        <a:rPr b="0" sz="500">
+                          <a:solidFill>
+                            <a:srgbClr val="000000"/>
+                          </a:solidFill>
+                          <a:latin typeface="Calibri"/>
+                        </a:rPr>
+                        <a:t>Key unlocks Version 2.0: higher query, series and year limits, plus net and percent changes, calculations and annual averages.</a:t>
+                      </a:r>
+                    </a:p>
+                  </a:txBody>
+                  <a:tcPr marT="9144" marB="9144">
+                    <a:solidFill>
+                      <a:srgbClr val="FFFFFF"/>
+                    </a:solidFill>
+                  </a:tcPr>
+                </a:tc>
+                <a:tc>
+                  <a:txBody>
+                    <a:bodyPr wrap="square"/>
+                    <a:lstStyle/>
+                    <a:p>
+                      <a:r>
+                        <a:rPr b="0" sz="500">
+                          <a:solidFill>
+                            <a:srgbClr val="000000"/>
+                          </a:solidFill>
+                          <a:latin typeface="Calibri"/>
+                        </a:rPr>
+                        <a:t>yes / no / no / yes</a:t>
+                      </a:r>
+                    </a:p>
+                  </a:txBody>
+                  <a:tcPr marT="9144" marB="9144">
+                    <a:solidFill>
+                      <a:srgbClr val="FFFFFF"/>
+                    </a:solidFill>
+                  </a:tcPr>
+                </a:tc>
+              </a:tr>
+              <a:tr h="109728">
+                <a:tc>
+                  <a:txBody>
+                    <a:bodyPr wrap="square"/>
+                    <a:lstStyle/>
+                    <a:p>
+                      <a:r>
+                        <a:rPr b="0" sz="500">
+                          <a:solidFill>
+                            <a:srgbClr val="000000"/>
+                          </a:solidFill>
+                          <a:latin typeface="Calibri"/>
+                        </a:rPr>
+                        <a:t>BTS</a:t>
+                      </a:r>
+                    </a:p>
+                  </a:txBody>
+                  <a:tcPr marT="9144" marB="9144">
+                    <a:solidFill>
+                      <a:srgbClr val="FFFFFF"/>
+                    </a:solidFill>
+                  </a:tcPr>
+                </a:tc>
+                <a:tc>
+                  <a:txBody>
+                    <a:bodyPr wrap="square"/>
+                    <a:lstStyle/>
+                    <a:p>
+                      <a:r>
+                        <a:rPr b="0" sz="500">
+                          <a:solidFill>
+                            <a:srgbClr val="000000"/>
+                          </a:solidFill>
+                          <a:latin typeface="Calibri"/>
+                        </a:rPr>
+                        <a:t>not determined: www.bts.gov refused every fetch (HTTP 403); its data portal data.bts.gov answered a request without a key, but no BTS page read states API terms</a:t>
+                      </a:r>
+                    </a:p>
+                  </a:txBody>
+                  <a:tcPr marT="9144" marB="9144">
+                    <a:solidFill>
+                      <a:srgbClr val="FFFFFF"/>
+                    </a:solidFill>
+                  </a:tcPr>
+                </a:tc>
+                <a:tc>
+                  <a:txBody>
+                    <a:bodyPr wrap="square"/>
+                    <a:lstStyle/>
+                    <a:p>
+                      <a:r>
+                        <a:rPr b="0" sz="500">
+                          <a:solidFill>
+                            <a:srgbClr val="000000"/>
+                          </a:solidFill>
+                          <a:latin typeface="Calibri"/>
+                        </a:rPr>
+                        <a:t>not stated</a:t>
+                      </a:r>
+                    </a:p>
+                  </a:txBody>
+                  <a:tcPr marT="9144" marB="9144">
+                    <a:solidFill>
+                      <a:srgbClr val="FFFFFF"/>
+                    </a:solidFill>
+                  </a:tcPr>
+                </a:tc>
+                <a:tc>
+                  <a:txBody>
+                    <a:bodyPr wrap="square"/>
+                    <a:lstStyle/>
+                    <a:p>
+                      <a:r>
+                        <a:rPr b="0" sz="500">
+                          <a:solidFill>
+                            <a:srgbClr val="000000"/>
+                          </a:solidFill>
+                          <a:latin typeface="Calibri"/>
+                        </a:rPr>
+                        <a:t>not stated</a:t>
+                      </a:r>
+                    </a:p>
+                  </a:txBody>
+                  <a:tcPr marT="9144" marB="9144">
+                    <a:solidFill>
+                      <a:srgbClr val="FFFFFF"/>
+                    </a:solidFill>
+                  </a:tcPr>
+                </a:tc>
+                <a:tc>
+                  <a:txBody>
+                    <a:bodyPr wrap="square"/>
+                    <a:lstStyle/>
+                    <a:p>
+                      <a:r>
+                        <a:rPr b="0" sz="500">
+                          <a:solidFill>
+                            <a:srgbClr val="000000"/>
+                          </a:solidFill>
+                          <a:latin typeface="Calibri"/>
+                        </a:rPr>
+                        <a:t>not stated</a:t>
+                      </a:r>
+                    </a:p>
+                  </a:txBody>
+                  <a:tcPr marT="9144" marB="9144">
+                    <a:solidFill>
+                      <a:srgbClr val="FFFFFF"/>
+                    </a:solidFill>
+                  </a:tcPr>
+                </a:tc>
+                <a:tc>
+                  <a:txBody>
+                    <a:bodyPr wrap="square"/>
+                    <a:lstStyle/>
+                    <a:p>
+                      <a:r>
+                        <a:rPr b="0" sz="500">
+                          <a:solidFill>
+                            <a:srgbClr val="000000"/>
+                          </a:solidFill>
+                          <a:latin typeface="Calibri"/>
+                        </a:rPr>
+                        <a:t>not determined / not determined / not determined / not determined</a:t>
+                      </a:r>
+                    </a:p>
+                  </a:txBody>
+                  <a:tcPr marT="9144" marB="9144">
+                    <a:solidFill>
+                      <a:srgbClr val="FFFFFF"/>
+                    </a:solidFill>
+                  </a:tcPr>
+                </a:tc>
+              </a:tr>
+              <a:tr h="109728">
+                <a:tc>
+                  <a:txBody>
+                    <a:bodyPr wrap="square"/>
+                    <a:lstStyle/>
+                    <a:p>
+                      <a:r>
+                        <a:rPr b="0" sz="500">
+                          <a:solidFill>
+                            <a:srgbClr val="000000"/>
+                          </a:solidFill>
+                          <a:latin typeface="Calibri"/>
+                        </a:rPr>
+                        <a:t>CENSUS</a:t>
+                      </a:r>
+                    </a:p>
+                  </a:txBody>
+                  <a:tcPr marT="9144" marB="9144">
+                    <a:solidFill>
+                      <a:srgbClr val="FFFFFF"/>
+                    </a:solidFill>
+                  </a:tcPr>
+                </a:tc>
+                <a:tc>
+                  <a:txBody>
+                    <a:bodyPr wrap="square"/>
+                    <a:lstStyle/>
+                    <a:p>
+                      <a:r>
+                        <a:rPr b="0" sz="500">
+                          <a:solidFill>
+                            <a:srgbClr val="000000"/>
+                          </a:solidFill>
+                          <a:latin typeface="Calibri"/>
+                        </a:rPr>
+                        <a:t>Census Data API, host api.census.gov/data (dataset paths appended, e.g. api.census.gov/data/2019/pep/charagegroups)</a:t>
+                      </a:r>
+                    </a:p>
+                  </a:txBody>
+                  <a:tcPr marT="9144" marB="9144">
+                    <a:solidFill>
+                      <a:srgbClr val="FFFFFF"/>
+                    </a:solidFill>
+                  </a:tcPr>
+                </a:tc>
+                <a:tc>
+                  <a:txBody>
+                    <a:bodyPr wrap="square"/>
+                    <a:lstStyle/>
+                    <a:p>
+                      <a:r>
+                        <a:rPr b="0" sz="500">
+                          <a:solidFill>
+                            <a:srgbClr val="000000"/>
+                          </a:solidFill>
+                          <a:latin typeface="Calibri"/>
+                        </a:rPr>
+                        <a:t>Key required on all data queries, passed in the URL as &amp;key=; up to 50 variables per query.</a:t>
+                      </a:r>
+                    </a:p>
+                  </a:txBody>
+                  <a:tcPr marT="9144" marB="9144">
+                    <a:solidFill>
+                      <a:srgbClr val="FFFFFF"/>
+                    </a:solidFill>
+                  </a:tcPr>
+                </a:tc>
+                <a:tc>
+                  <a:txBody>
+                    <a:bodyPr wrap="square"/>
+                    <a:lstStyle/>
+                    <a:p>
+                      <a:r>
+                        <a:rPr b="0" sz="500">
+                          <a:solidFill>
+                            <a:srgbClr val="000000"/>
+                          </a:solidFill>
+                          <a:latin typeface="Calibri"/>
+                        </a:rPr>
+                        <a:t>Free pop-up form; email must end .com, .net, .org, .gov or .edu; agree to terms; a person must click the emailed link to register (activate) the key. Other form fields not stated.</a:t>
+                      </a:r>
+                    </a:p>
+                  </a:txBody>
+                  <a:tcPr marT="9144" marB="9144">
+                    <a:solidFill>
+                      <a:srgbClr val="FFFFFF"/>
+                    </a:solidFill>
+                  </a:tcPr>
+                </a:tc>
+                <a:tc>
+                  <a:txBody>
+                    <a:bodyPr wrap="square"/>
+                    <a:lstStyle/>
+                    <a:p>
+                      <a:r>
+                        <a:rPr b="0" sz="500">
+                          <a:solidFill>
+                            <a:srgbClr val="000000"/>
+                          </a:solidFill>
+                          <a:latin typeface="Calibri"/>
+                        </a:rPr>
+                        <a:t>No keyless tier is stated; the key is required for every data query.</a:t>
+                      </a:r>
+                    </a:p>
+                  </a:txBody>
+                  <a:tcPr marT="9144" marB="9144">
+                    <a:solidFill>
+                      <a:srgbClr val="FFFFFF"/>
+                    </a:solidFill>
+                  </a:tcPr>
+                </a:tc>
+                <a:tc>
+                  <a:txBody>
+                    <a:bodyPr wrap="square"/>
+                    <a:lstStyle/>
+                    <a:p>
+                      <a:r>
+                        <a:rPr b="0" sz="500">
+                          <a:solidFill>
+                            <a:srgbClr val="000000"/>
+                          </a:solidFill>
+                          <a:latin typeface="Calibri"/>
+                        </a:rPr>
+                        <a:t>yes / yes / no / yes</a:t>
+                      </a:r>
+                    </a:p>
+                  </a:txBody>
+                  <a:tcPr marT="9144" marB="9144">
+                    <a:solidFill>
+                      <a:srgbClr val="FFFFFF"/>
+                    </a:solidFill>
+                  </a:tcPr>
+                </a:tc>
+              </a:tr>
+              <a:tr h="109728">
+                <a:tc>
+                  <a:txBody>
+                    <a:bodyPr wrap="square"/>
+                    <a:lstStyle/>
+                    <a:p>
+                      <a:r>
+                        <a:rPr b="0" sz="500">
+                          <a:solidFill>
+                            <a:srgbClr val="000000"/>
+                          </a:solidFill>
+                          <a:latin typeface="Calibri"/>
+                        </a:rPr>
+                        <a:t>DRSMSU</a:t>
+                      </a:r>
+                    </a:p>
+                  </a:txBody>
+                  <a:tcPr marT="9144" marB="9144">
+                    <a:solidFill>
+                      <a:srgbClr val="FFFFFF"/>
+                    </a:solidFill>
+                  </a:tcPr>
+                </a:tc>
+                <a:tc>
+                  <a:txBody>
+                    <a:bodyPr wrap="square"/>
+                    <a:lstStyle/>
+                    <a:p>
+                      <a:r>
+                        <a:rPr b="0" sz="500">
+                          <a:solidFill>
+                            <a:srgbClr val="000000"/>
+                          </a:solidFill>
+                          <a:latin typeface="Calibri"/>
+                        </a:rPr>
+                        <a:t>no Board API found; for Data Download Program series the Board points to the St. Louis Fed's FRED API (api.stlouisfed.org). SCF is not a DDP release; offered as file downloads</a:t>
+                      </a:r>
+                    </a:p>
+                  </a:txBody>
+                  <a:tcPr marT="9144" marB="9144">
+                    <a:solidFill>
+                      <a:srgbClr val="FFFFFF"/>
+                    </a:solidFill>
+                  </a:tcPr>
+                </a:tc>
+                <a:tc>
+                  <a:txBody>
+                    <a:bodyPr wrap="square"/>
+                    <a:lstStyle/>
+                    <a:p>
+                      <a:r>
+                        <a:rPr b="0" sz="500">
+                          <a:solidFill>
+                            <a:srgbClr val="000000"/>
+                          </a:solidFill>
+                          <a:latin typeface="Calibri"/>
+                        </a:rPr>
+                        <a:t>FRED API: key required, sent in the address (api_key=) or, for Version 2, in an HTTP header</a:t>
+                      </a:r>
+                    </a:p>
+                  </a:txBody>
+                  <a:tcPr marT="9144" marB="9144">
+                    <a:solidFill>
+                      <a:srgbClr val="FFFFFF"/>
+                    </a:solidFill>
+                  </a:tcPr>
+                </a:tc>
+                <a:tc>
+                  <a:txBody>
+                    <a:bodyPr wrap="square"/>
+                    <a:lstStyle/>
+                    <a:p>
+                      <a:r>
+                        <a:rPr b="0" sz="500">
+                          <a:solidFill>
+                            <a:srgbClr val="000000"/>
+                          </a:solidFill>
+                          <a:latin typeface="Calibri"/>
+                        </a:rPr>
+                        <a:t>register a FRED user account with the St. Louis Fed; what registration asks for and any email step are not stated on federalreserve.gov</a:t>
+                      </a:r>
+                    </a:p>
+                  </a:txBody>
+                  <a:tcPr marT="9144" marB="9144">
+                    <a:solidFill>
+                      <a:srgbClr val="FFFFFF"/>
+                    </a:solidFill>
+                  </a:tcPr>
+                </a:tc>
+                <a:tc>
+                  <a:txBody>
+                    <a:bodyPr wrap="square"/>
+                    <a:lstStyle/>
+                    <a:p>
+                      <a:r>
+                        <a:rPr b="0" sz="500">
+                          <a:solidFill>
+                            <a:srgbClr val="000000"/>
+                          </a:solidFill>
+                          <a:latin typeface="Calibri"/>
+                        </a:rPr>
+                        <a:t>not stated</a:t>
+                      </a:r>
+                    </a:p>
+                  </a:txBody>
+                  <a:tcPr marT="9144" marB="9144">
+                    <a:solidFill>
+                      <a:srgbClr val="FFFFFF"/>
+                    </a:solidFill>
+                  </a:tcPr>
+                </a:tc>
+                <a:tc>
+                  <a:txBody>
+                    <a:bodyPr wrap="square"/>
+                    <a:lstStyle/>
+                    <a:p>
+                      <a:r>
+                        <a:rPr b="0" sz="500">
+                          <a:solidFill>
+                            <a:srgbClr val="000000"/>
+                          </a:solidFill>
+                          <a:latin typeface="Calibri"/>
+                        </a:rPr>
+                        <a:t>no / no / no / no</a:t>
+                      </a:r>
+                    </a:p>
+                  </a:txBody>
+                  <a:tcPr marT="9144" marB="9144">
+                    <a:solidFill>
+                      <a:srgbClr val="FFFFFF"/>
+                    </a:solidFill>
+                  </a:tcPr>
+                </a:tc>
+              </a:tr>
+              <a:tr h="109728">
+                <a:tc>
+                  <a:txBody>
+                    <a:bodyPr wrap="square"/>
+                    <a:lstStyle/>
+                    <a:p>
+                      <a:r>
+                        <a:rPr b="0" sz="500">
+                          <a:solidFill>
+                            <a:srgbClr val="000000"/>
+                          </a:solidFill>
+                          <a:latin typeface="Calibri"/>
+                        </a:rPr>
+                        <a:t>EIA</a:t>
+                      </a:r>
+                    </a:p>
+                  </a:txBody>
+                  <a:tcPr marT="9144" marB="9144">
+                    <a:solidFill>
+                      <a:srgbClr val="FFFFFF"/>
+                    </a:solidFill>
+                  </a:tcPr>
+                </a:tc>
+                <a:tc>
+                  <a:txBody>
+                    <a:bodyPr wrap="square"/>
+                    <a:lstStyle/>
+                    <a:p>
+                      <a:r>
+                        <a:rPr b="0" sz="500">
+                          <a:solidFill>
+                            <a:srgbClr val="000000"/>
+                          </a:solidFill>
+                          <a:latin typeface="Calibri"/>
+                        </a:rPr>
+                        <a:t>EIA Open Data API (APIv2), base address https://api.eia.gov/v2/</a:t>
+                      </a:r>
+                    </a:p>
+                  </a:txBody>
+                  <a:tcPr marT="9144" marB="9144">
+                    <a:solidFill>
+                      <a:srgbClr val="FFFFFF"/>
+                    </a:solidFill>
+                  </a:tcPr>
+                </a:tc>
+                <a:tc>
+                  <a:txBody>
+                    <a:bodyPr wrap="square"/>
+                    <a:lstStyle/>
+                    <a:p>
+                      <a:r>
+                        <a:rPr b="0" sz="500">
+                          <a:solidFill>
+                            <a:srgbClr val="000000"/>
+                          </a:solidFill>
+                          <a:latin typeface="Calibri"/>
+                        </a:rPr>
+                        <a:t>Key required on every call, passed in the URL as api_key; not read from HTTP headers. Requests must be throttled; per-second and per-hour numbers not stated</a:t>
+                      </a:r>
+                    </a:p>
+                  </a:txBody>
+                  <a:tcPr marT="9144" marB="9144">
+                    <a:solidFill>
+                      <a:srgbClr val="FFFFFF"/>
+                    </a:solidFill>
+                  </a:tcPr>
+                </a:tc>
+                <a:tc>
+                  <a:txBody>
+                    <a:bodyPr wrap="square"/>
+                    <a:lstStyle/>
+                    <a:p>
+                      <a:r>
+                        <a:rPr b="0" sz="500">
+                          <a:solidFill>
+                            <a:srgbClr val="000000"/>
+                          </a:solidFill>
+                          <a:latin typeface="Calibri"/>
+                        </a:rPr>
+                        <a:t>Form asks first name, last name, email, user category, reason for use, and agreement to terms; key is sent by email, so a person must open that email. No activation link stated</a:t>
+                      </a:r>
+                    </a:p>
+                  </a:txBody>
+                  <a:tcPr marT="9144" marB="9144">
+                    <a:solidFill>
+                      <a:srgbClr val="FFFFFF"/>
+                    </a:solidFill>
+                  </a:tcPr>
+                </a:tc>
+                <a:tc>
+                  <a:txBody>
+                    <a:bodyPr wrap="square"/>
+                    <a:lstStyle/>
+                    <a:p>
+                      <a:r>
+                        <a:rPr b="0" sz="500">
+                          <a:solidFill>
+                            <a:srgbClr val="000000"/>
+                          </a:solidFill>
+                          <a:latin typeface="Calibri"/>
+                        </a:rPr>
+                        <a:t>No key, no API access; the key is the unit EIA throttles and can suspend. Bulk download needs no key. No tiered limits stated</a:t>
+                      </a:r>
+                    </a:p>
+                  </a:txBody>
+                  <a:tcPr marT="9144" marB="9144">
+                    <a:solidFill>
+                      <a:srgbClr val="FFFFFF"/>
+                    </a:solidFill>
+                  </a:tcPr>
+                </a:tc>
+                <a:tc>
+                  <a:txBody>
+                    <a:bodyPr wrap="square"/>
+                    <a:lstStyle/>
+                    <a:p>
+                      <a:r>
+                        <a:rPr b="0" sz="500">
+                          <a:solidFill>
+                            <a:srgbClr val="000000"/>
+                          </a:solidFill>
+                          <a:latin typeface="Calibri"/>
+                        </a:rPr>
+                        <a:t>yes / yes / no / yes</a:t>
+                      </a:r>
+                    </a:p>
+                  </a:txBody>
+                  <a:tcPr marT="9144" marB="9144">
+                    <a:solidFill>
+                      <a:srgbClr val="FFFFFF"/>
+                    </a:solidFill>
+                  </a:tcPr>
+                </a:tc>
+              </a:tr>
+              <a:tr h="109728">
+                <a:tc>
+                  <a:txBody>
+                    <a:bodyPr wrap="square"/>
+                    <a:lstStyle/>
+                    <a:p>
+                      <a:r>
+                        <a:rPr b="0" sz="500">
+                          <a:solidFill>
+                            <a:srgbClr val="000000"/>
+                          </a:solidFill>
+                          <a:latin typeface="Calibri"/>
+                        </a:rPr>
+                        <a:t>ERS</a:t>
+                      </a:r>
+                    </a:p>
+                  </a:txBody>
+                  <a:tcPr marT="9144" marB="9144">
+                    <a:solidFill>
+                      <a:srgbClr val="FFFFFF"/>
+                    </a:solidFill>
+                  </a:tcPr>
+                </a:tc>
+                <a:tc>
+                  <a:txBody>
+                    <a:bodyPr wrap="square"/>
+                    <a:lstStyle/>
+                    <a:p>
+                      <a:r>
+                        <a:rPr b="0" sz="500">
+                          <a:solidFill>
+                            <a:srgbClr val="000000"/>
+                          </a:solidFill>
+                          <a:latin typeface="Calibri"/>
+                        </a:rPr>
+                        <a:t>ERS Data APIs (ARMS Data API), REST base https://api.ers.usda.gov/data/ with GraphQL at https://api.ers.usda.gov/data/arms/graphql</a:t>
+                      </a:r>
+                    </a:p>
+                  </a:txBody>
+                  <a:tcPr marT="9144" marB="9144">
+                    <a:solidFill>
+                      <a:srgbClr val="FFFFFF"/>
+                    </a:solidFill>
+                  </a:tcPr>
+                </a:tc>
+                <a:tc>
+                  <a:txBody>
+                    <a:bodyPr wrap="square"/>
+                    <a:lstStyle/>
+                    <a:p>
+                      <a:r>
+                        <a:rPr b="0" sz="500">
+                          <a:solidFill>
+                            <a:srgbClr val="000000"/>
+                          </a:solidFill>
+                          <a:latin typeface="Calibri"/>
+                        </a:rPr>
+                        <a:t>Key required, passed in the URL as api_key; no limit stated by ERS</a:t>
+                      </a:r>
+                    </a:p>
+                  </a:txBody>
+                  <a:tcPr marT="9144" marB="9144">
+                    <a:solidFill>
+                      <a:srgbClr val="FFFFFF"/>
+                    </a:solidFill>
+                  </a:tcPr>
+                </a:tc>
+                <a:tc>
+                  <a:txBody>
+                    <a:bodyPr wrap="square"/>
+                    <a:lstStyle/>
+                    <a:p>
+                      <a:r>
+                        <a:rPr b="0" sz="500">
+                          <a:solidFill>
+                            <a:srgbClr val="000000"/>
+                          </a:solidFill>
+                          <a:latin typeface="Calibri"/>
+                        </a:rPr>
+                        <a:t>api.data.gov signup form asks name and a valid email; key is sent automatically to that email, so a person must open it. No activation link stated (key issued through api.data.gov)</a:t>
+                      </a:r>
+                    </a:p>
+                  </a:txBody>
+                  <a:tcPr marT="9144" marB="9144">
+                    <a:solidFill>
+                      <a:srgbClr val="FFFFFF"/>
+                    </a:solidFill>
+                  </a:tcPr>
+                </a:tc>
+                <a:tc>
+                  <a:txBody>
+                    <a:bodyPr wrap="square"/>
+                    <a:lstStyle/>
+                    <a:p>
+                      <a:r>
+                        <a:rPr b="0" sz="500">
+                          <a:solidFill>
+                            <a:srgbClr val="000000"/>
+                          </a:solidFill>
+                          <a:latin typeface="Calibri"/>
+                        </a:rPr>
+                        <a:t>Key is required for access, lets ERS notify users of API changes, and works across Open Government APIs on the shared service. No limits stated</a:t>
+                      </a:r>
+                    </a:p>
+                  </a:txBody>
+                  <a:tcPr marT="9144" marB="9144">
+                    <a:solidFill>
+                      <a:srgbClr val="FFFFFF"/>
+                    </a:solidFill>
+                  </a:tcPr>
+                </a:tc>
+                <a:tc>
+                  <a:txBody>
+                    <a:bodyPr wrap="square"/>
+                    <a:lstStyle/>
+                    <a:p>
+                      <a:r>
+                        <a:rPr b="0" sz="500">
+                          <a:solidFill>
+                            <a:srgbClr val="000000"/>
+                          </a:solidFill>
+                          <a:latin typeface="Calibri"/>
+                        </a:rPr>
+                        <a:t>yes / not determined / no / no</a:t>
+                      </a:r>
+                    </a:p>
+                  </a:txBody>
+                  <a:tcPr marT="9144" marB="9144">
+                    <a:solidFill>
+                      <a:srgbClr val="FFFFFF"/>
+                    </a:solidFill>
+                  </a:tcPr>
+                </a:tc>
+              </a:tr>
+              <a:tr h="109728">
+                <a:tc>
+                  <a:txBody>
+                    <a:bodyPr wrap="square"/>
+                    <a:lstStyle/>
+                    <a:p>
+                      <a:r>
+                        <a:rPr b="0" sz="500">
+                          <a:solidFill>
+                            <a:srgbClr val="000000"/>
+                          </a:solidFill>
+                          <a:latin typeface="Calibri"/>
+                        </a:rPr>
+                        <a:t>NAHMSAPHIS</a:t>
+                      </a:r>
+                    </a:p>
+                  </a:txBody>
+                  <a:tcPr marT="9144" marB="9144">
+                    <a:solidFill>
+                      <a:srgbClr val="FFFFFF"/>
+                    </a:solidFill>
+                  </a:tcPr>
+                </a:tc>
+                <a:tc>
+                  <a:txBody>
+                    <a:bodyPr wrap="square"/>
+                    <a:lstStyle/>
+                    <a:p>
+                      <a:r>
+                        <a:rPr b="0" sz="500">
+                          <a:solidFill>
+                            <a:srgbClr val="000000"/>
+                          </a:solidFill>
+                          <a:latin typeface="Calibri"/>
+                        </a:rPr>
+                        <a:t>no public API found</a:t>
+                      </a:r>
+                    </a:p>
+                  </a:txBody>
+                  <a:tcPr marT="9144" marB="9144">
+                    <a:solidFill>
+                      <a:srgbClr val="FFFFFF"/>
+                    </a:solidFill>
+                  </a:tcPr>
+                </a:tc>
+                <a:tc>
+                  <a:txBody>
+                    <a:bodyPr wrap="square"/>
+                    <a:lstStyle/>
+                    <a:p>
+                      <a:r>
+                        <a:rPr b="0" sz="500">
+                          <a:solidFill>
+                            <a:srgbClr val="000000"/>
+                          </a:solidFill>
+                          <a:latin typeface="Calibri"/>
+                        </a:rPr>
+                        <a:t>not stated</a:t>
+                      </a:r>
+                    </a:p>
+                  </a:txBody>
+                  <a:tcPr marT="9144" marB="9144">
+                    <a:solidFill>
+                      <a:srgbClr val="FFFFFF"/>
+                    </a:solidFill>
+                  </a:tcPr>
+                </a:tc>
+                <a:tc>
+                  <a:txBody>
+                    <a:bodyPr wrap="square"/>
+                    <a:lstStyle/>
+                    <a:p>
+                      <a:r>
+                        <a:rPr b="0" sz="500">
+                          <a:solidFill>
+                            <a:srgbClr val="000000"/>
+                          </a:solidFill>
+                          <a:latin typeface="Calibri"/>
+                        </a:rPr>
+                        <a:t>not stated</a:t>
+                      </a:r>
+                    </a:p>
+                  </a:txBody>
+                  <a:tcPr marT="9144" marB="9144">
+                    <a:solidFill>
+                      <a:srgbClr val="FFFFFF"/>
+                    </a:solidFill>
+                  </a:tcPr>
+                </a:tc>
+                <a:tc>
+                  <a:txBody>
+                    <a:bodyPr wrap="square"/>
+                    <a:lstStyle/>
+                    <a:p>
+                      <a:r>
+                        <a:rPr b="0" sz="500">
+                          <a:solidFill>
+                            <a:srgbClr val="000000"/>
+                          </a:solidFill>
+                          <a:latin typeface="Calibri"/>
+                        </a:rPr>
+                        <a:t>not stated</a:t>
+                      </a:r>
+                    </a:p>
+                  </a:txBody>
+                  <a:tcPr marT="9144" marB="9144">
+                    <a:solidFill>
+                      <a:srgbClr val="FFFFFF"/>
+                    </a:solidFill>
+                  </a:tcPr>
+                </a:tc>
+                <a:tc>
+                  <a:txBody>
+                    <a:bodyPr wrap="square"/>
+                    <a:lstStyle/>
+                    <a:p>
+                      <a:r>
+                        <a:rPr b="0" sz="500">
+                          <a:solidFill>
+                            <a:srgbClr val="000000"/>
+                          </a:solidFill>
+                          <a:latin typeface="Calibri"/>
+                        </a:rPr>
+                        <a:t>no / not determined / no / no</a:t>
+                      </a:r>
+                    </a:p>
+                  </a:txBody>
+                  <a:tcPr marT="9144" marB="9144">
+                    <a:solidFill>
+                      <a:srgbClr val="FFFFFF"/>
+                    </a:solidFill>
+                  </a:tcPr>
+                </a:tc>
+              </a:tr>
+              <a:tr h="109728">
+                <a:tc>
+                  <a:txBody>
+                    <a:bodyPr wrap="square"/>
+                    <a:lstStyle/>
+                    <a:p>
+                      <a:r>
+                        <a:rPr b="0" sz="500">
+                          <a:solidFill>
+                            <a:srgbClr val="000000"/>
+                          </a:solidFill>
+                          <a:latin typeface="Calibri"/>
+                        </a:rPr>
+                        <a:t>NASS</a:t>
+                      </a:r>
+                    </a:p>
+                  </a:txBody>
+                  <a:tcPr marT="9144" marB="9144">
+                    <a:solidFill>
+                      <a:srgbClr val="FFFFFF"/>
+                    </a:solidFill>
+                  </a:tcPr>
+                </a:tc>
+                <a:tc>
+                  <a:txBody>
+                    <a:bodyPr wrap="square"/>
+                    <a:lstStyle/>
+                    <a:p>
+                      <a:r>
+                        <a:rPr b="0" sz="500">
+                          <a:solidFill>
+                            <a:srgbClr val="000000"/>
+                          </a:solidFill>
+                          <a:latin typeface="Calibri"/>
+                        </a:rPr>
+                        <a:t>Quick Stats API, base address https://quickstats.nass.usda.gov/api/ (resources api_GET, get_param_values, get_counts)</a:t>
+                      </a:r>
+                    </a:p>
+                  </a:txBody>
+                  <a:tcPr marT="9144" marB="9144">
+                    <a:solidFill>
+                      <a:srgbClr val="FFFFFF"/>
+                    </a:solidFill>
+                  </a:tcPr>
+                </a:tc>
+                <a:tc>
+                  <a:txBody>
+                    <a:bodyPr wrap="square"/>
+                    <a:lstStyle/>
+                    <a:p>
+                      <a:r>
+                        <a:rPr b="0" sz="500">
+                          <a:solidFill>
+                            <a:srgbClr val="000000"/>
+                          </a:solidFill>
+                          <a:latin typeface="Calibri"/>
+                        </a:rPr>
+                        <a:t>Key required, passed in the URL as key=. Each request returns at most 50,000 records; no rate limit stated</a:t>
+                      </a:r>
+                    </a:p>
+                  </a:txBody>
+                  <a:tcPr marT="9144" marB="9144">
+                    <a:solidFill>
+                      <a:srgbClr val="FFFFFF"/>
+                    </a:solidFill>
+                  </a:tcPr>
+                </a:tc>
+                <a:tc>
+                  <a:txBody>
+                    <a:bodyPr wrap="square"/>
+                    <a:lstStyle/>
+                    <a:p>
+                      <a:r>
+                        <a:rPr b="0" sz="500">
+                          <a:solidFill>
+                            <a:srgbClr val="000000"/>
+                          </a:solidFill>
+                          <a:latin typeface="Calibri"/>
+                        </a:rPr>
+                        <a:t>Form asks email (required) and name/organization (optional), plus agreeing to the Terms of Service; key arrives by email, no activation link stated</a:t>
+                      </a:r>
+                    </a:p>
+                  </a:txBody>
+                  <a:tcPr marT="9144" marB="9144">
+                    <a:solidFill>
+                      <a:srgbClr val="FFFFFF"/>
+                    </a:solidFill>
+                  </a:tcPr>
+                </a:tc>
+                <a:tc>
+                  <a:txBody>
+                    <a:bodyPr wrap="square"/>
+                    <a:lstStyle/>
+                    <a:p>
+                      <a:r>
+                        <a:rPr b="0" sz="500">
+                          <a:solidFill>
+                            <a:srgbClr val="000000"/>
+                          </a:solidFill>
+                          <a:latin typeface="Calibri"/>
+                        </a:rPr>
+                        <a:t>not stated</a:t>
+                      </a:r>
+                    </a:p>
+                  </a:txBody>
+                  <a:tcPr marT="9144" marB="9144">
+                    <a:solidFill>
+                      <a:srgbClr val="FFFFFF"/>
+                    </a:solidFill>
+                  </a:tcPr>
+                </a:tc>
+                <a:tc>
+                  <a:txBody>
+                    <a:bodyPr wrap="square"/>
+                    <a:lstStyle/>
+                    <a:p>
+                      <a:r>
+                        <a:rPr b="0" sz="500">
+                          <a:solidFill>
+                            <a:srgbClr val="000000"/>
+                          </a:solidFill>
+                          <a:latin typeface="Calibri"/>
+                        </a:rPr>
+                        <a:t>yes / not determined / no / yes</a:t>
+                      </a:r>
+                    </a:p>
+                  </a:txBody>
+                  <a:tcPr marT="9144" marB="9144">
+                    <a:solidFill>
+                      <a:srgbClr val="FFFFFF"/>
+                    </a:solidFill>
+                  </a:tcPr>
+                </a:tc>
+              </a:tr>
+              <a:tr h="109728">
+                <a:tc>
+                  <a:txBody>
+                    <a:bodyPr wrap="square"/>
+                    <a:lstStyle/>
+                    <a:p>
+                      <a:r>
+                        <a:rPr b="0" sz="500">
+                          <a:solidFill>
+                            <a:srgbClr val="000000"/>
+                          </a:solidFill>
+                          <a:latin typeface="Calibri"/>
+                        </a:rPr>
+                        <a:t>NCES</a:t>
+                      </a:r>
+                    </a:p>
+                  </a:txBody>
+                  <a:tcPr marT="9144" marB="9144">
+                    <a:solidFill>
+                      <a:srgbClr val="FFFFFF"/>
+                    </a:solidFill>
+                  </a:tcPr>
+                </a:tc>
+                <a:tc>
+                  <a:txBody>
+                    <a:bodyPr wrap="square"/>
+                    <a:lstStyle/>
+                    <a:p>
+                      <a:r>
+                        <a:rPr b="0" sz="500">
+                          <a:solidFill>
+                            <a:srgbClr val="000000"/>
+                          </a:solidFill>
+                          <a:latin typeface="Calibri"/>
+                        </a:rPr>
+                        <a:t>No NCES data API documented on NCES pages; EDGE geodata are offered as GIS web services via an off-site ArcGIS Open Data site. ED's College Scorecard API (https://api.data.gov/ed/collegescorecard/v1/schools) is departmental, not NCES</a:t>
+                      </a:r>
+                    </a:p>
+                  </a:txBody>
+                  <a:tcPr marT="9144" marB="9144">
+                    <a:solidFill>
+                      <a:srgbClr val="FFFFFF"/>
+                    </a:solidFill>
+                  </a:tcPr>
+                </a:tc>
+                <a:tc>
+                  <a:txBody>
+                    <a:bodyPr wrap="square"/>
+                    <a:lstStyle/>
+                    <a:p>
+                      <a:r>
+                        <a:rPr b="0" sz="500">
+                          <a:solidFill>
+                            <a:srgbClr val="000000"/>
+                          </a:solidFill>
+                          <a:latin typeface="Calibri"/>
+                        </a:rPr>
+                        <a:t>NCES EDGE services: not stated. College Scorecard (ED, not NCES): key required on every request, passed in the address as api_key; default 1,000 requests per IP address per hour</a:t>
+                      </a:r>
+                    </a:p>
+                  </a:txBody>
+                  <a:tcPr marT="9144" marB="9144">
+                    <a:solidFill>
+                      <a:srgbClr val="FFFFFF"/>
+                    </a:solidFill>
+                  </a:tcPr>
+                </a:tc>
+                <a:tc>
+                  <a:txBody>
+                    <a:bodyPr wrap="square"/>
+                    <a:lstStyle/>
+                    <a:p>
+                      <a:r>
+                        <a:rPr b="0" sz="500">
+                          <a:solidFill>
+                            <a:srgbClr val="000000"/>
+                          </a:solidFill>
+                          <a:latin typeface="Calibri"/>
+                        </a:rPr>
+                        <a:t>College Scorecard: security challenge, then a registration form (fields not stated); the key is emailed, so a person must open an email to receive it. NCES: not stated</a:t>
+                      </a:r>
+                    </a:p>
+                  </a:txBody>
+                  <a:tcPr marT="9144" marB="9144">
+                    <a:solidFill>
+                      <a:srgbClr val="FFFFFF"/>
+                    </a:solidFill>
+                  </a:tcPr>
+                </a:tc>
+                <a:tc>
+                  <a:txBody>
+                    <a:bodyPr wrap="square"/>
+                    <a:lstStyle/>
+                    <a:p>
+                      <a:r>
+                        <a:rPr b="0" sz="500">
+                          <a:solidFill>
+                            <a:srgbClr val="000000"/>
+                          </a:solidFill>
+                          <a:latin typeface="Calibri"/>
+                        </a:rPr>
+                        <a:t>not stated; College Scorecard has no keyless tier, the key is required for all requests</a:t>
+                      </a:r>
+                    </a:p>
+                  </a:txBody>
+                  <a:tcPr marT="9144" marB="9144">
+                    <a:solidFill>
+                      <a:srgbClr val="FFFFFF"/>
+                    </a:solidFill>
+                  </a:tcPr>
+                </a:tc>
+                <a:tc>
+                  <a:txBody>
+                    <a:bodyPr wrap="square"/>
+                    <a:lstStyle/>
+                    <a:p>
+                      <a:r>
+                        <a:rPr b="0" sz="500">
+                          <a:solidFill>
+                            <a:srgbClr val="000000"/>
+                          </a:solidFill>
+                          <a:latin typeface="Calibri"/>
+                        </a:rPr>
+                        <a:t>no / not determined / no / no</a:t>
+                      </a:r>
+                    </a:p>
+                  </a:txBody>
+                  <a:tcPr marT="9144" marB="9144">
+                    <a:solidFill>
+                      <a:srgbClr val="FFFFFF"/>
+                    </a:solidFill>
+                  </a:tcPr>
+                </a:tc>
+              </a:tr>
+              <a:tr h="109728">
+                <a:tc>
+                  <a:txBody>
+                    <a:bodyPr wrap="square"/>
+                    <a:lstStyle/>
+                    <a:p>
+                      <a:r>
+                        <a:rPr b="0" sz="500">
+                          <a:solidFill>
+                            <a:srgbClr val="000000"/>
+                          </a:solidFill>
+                          <a:latin typeface="Calibri"/>
+                        </a:rPr>
+                        <a:t>NCHS</a:t>
+                      </a:r>
+                    </a:p>
+                  </a:txBody>
+                  <a:tcPr marT="9144" marB="9144">
+                    <a:solidFill>
+                      <a:srgbClr val="FFFFFF"/>
+                    </a:solidFill>
+                  </a:tcPr>
+                </a:tc>
+                <a:tc>
+                  <a:txBody>
+                    <a:bodyPr wrap="square"/>
+                    <a:lstStyle/>
+                    <a:p>
+                      <a:r>
+                        <a:rPr b="0" sz="500">
+                          <a:solidFill>
+                            <a:srgbClr val="000000"/>
+                          </a:solidFill>
+                          <a:latin typeface="Calibri"/>
+                        </a:rPr>
+                        <a:t>CDC WONDER API, POST to https://wonder.cdc.gov/controller/datarequest/[database ID]; national NVSS data only. data.cdc.gov (Socrata) is also used, but its API terms are only on non-.gov dev.socrata.com</a:t>
+                      </a:r>
+                    </a:p>
+                  </a:txBody>
+                  <a:tcPr marT="9144" marB="9144">
+                    <a:solidFill>
+                      <a:srgbClr val="FFFFFF"/>
+                    </a:solidFill>
+                  </a:tcPr>
+                </a:tc>
+                <a:tc>
+                  <a:txBody>
+                    <a:bodyPr wrap="square"/>
+                    <a:lstStyle/>
+                    <a:p>
+                      <a:r>
+                        <a:rPr b="0" sz="500">
+                          <a:solidFill>
+                            <a:srgbClr val="000000"/>
+                          </a:solidFill>
+                          <a:latin typeface="Calibri"/>
+                        </a:rPr>
+                        <a:t>WONDER: no key described; POST request with XML, and consent to data use restrictions required in each request. data.cdc.gov app token terms: not stated on .gov pages</a:t>
+                      </a:r>
+                    </a:p>
+                  </a:txBody>
+                  <a:tcPr marT="9144" marB="9144">
+                    <a:solidFill>
+                      <a:srgbClr val="FFFFFF"/>
+                    </a:solidFill>
+                  </a:tcPr>
+                </a:tc>
+                <a:tc>
+                  <a:txBody>
+                    <a:bodyPr wrap="square"/>
+                    <a:lstStyle/>
+                    <a:p>
+                      <a:r>
+                        <a:rPr b="0" sz="500">
+                          <a:solidFill>
+                            <a:srgbClr val="000000"/>
+                          </a:solidFill>
+                          <a:latin typeface="Calibri"/>
+                        </a:rPr>
+                        <a:t>not stated</a:t>
+                      </a:r>
+                    </a:p>
+                  </a:txBody>
+                  <a:tcPr marT="9144" marB="9144">
+                    <a:solidFill>
+                      <a:srgbClr val="FFFFFF"/>
+                    </a:solidFill>
+                  </a:tcPr>
+                </a:tc>
+                <a:tc>
+                  <a:txBody>
+                    <a:bodyPr wrap="square"/>
+                    <a:lstStyle/>
+                    <a:p>
+                      <a:r>
+                        <a:rPr b="0" sz="500">
+                          <a:solidFill>
+                            <a:srgbClr val="000000"/>
+                          </a:solidFill>
+                          <a:latin typeface="Calibri"/>
+                        </a:rPr>
+                        <a:t>not stated</a:t>
+                      </a:r>
+                    </a:p>
+                  </a:txBody>
+                  <a:tcPr marT="9144" marB="9144">
+                    <a:solidFill>
+                      <a:srgbClr val="FFFFFF"/>
+                    </a:solidFill>
+                  </a:tcPr>
+                </a:tc>
+                <a:tc>
+                  <a:txBody>
+                    <a:bodyPr wrap="square"/>
+                    <a:lstStyle/>
+                    <a:p>
+                      <a:r>
+                        <a:rPr b="0" sz="500">
+                          <a:solidFill>
+                            <a:srgbClr val="000000"/>
+                          </a:solidFill>
+                          <a:latin typeface="Calibri"/>
+                        </a:rPr>
+                        <a:t>no / not determined / no / no</a:t>
+                      </a:r>
+                    </a:p>
+                  </a:txBody>
+                  <a:tcPr marT="9144" marB="9144">
+                    <a:solidFill>
+                      <a:srgbClr val="FFFFFF"/>
+                    </a:solidFill>
+                  </a:tcPr>
+                </a:tc>
+              </a:tr>
+              <a:tr h="109728">
+                <a:tc>
+                  <a:txBody>
+                    <a:bodyPr wrap="square"/>
+                    <a:lstStyle/>
+                    <a:p>
+                      <a:r>
+                        <a:rPr b="0" sz="500">
+                          <a:solidFill>
+                            <a:srgbClr val="000000"/>
+                          </a:solidFill>
+                          <a:latin typeface="Calibri"/>
+                        </a:rPr>
+                        <a:t>NCSES</a:t>
+                      </a:r>
+                    </a:p>
+                  </a:txBody>
+                  <a:tcPr marT="9144" marB="9144">
+                    <a:solidFill>
+                      <a:srgbClr val="FFFFFF"/>
+                    </a:solidFill>
+                  </a:tcPr>
+                </a:tc>
+                <a:tc>
+                  <a:txBody>
+                    <a:bodyPr wrap="square"/>
+                    <a:lstStyle/>
+                    <a:p>
+                      <a:r>
+                        <a:rPr b="0" sz="500">
+                          <a:solidFill>
+                            <a:srgbClr val="000000"/>
+                          </a:solidFill>
+                          <a:latin typeface="Calibri"/>
+                        </a:rPr>
+                        <a:t>no public API found; NCSES offers interactive web tools (Data Explorer, Chart Builder, Table Builder on ncsesdata.nsf.gov) and file downloads, none documented as an API</a:t>
+                      </a:r>
+                    </a:p>
+                  </a:txBody>
+                  <a:tcPr marT="9144" marB="9144">
+                    <a:solidFill>
+                      <a:srgbClr val="FFFFFF"/>
+                    </a:solidFill>
+                  </a:tcPr>
+                </a:tc>
+                <a:tc>
+                  <a:txBody>
+                    <a:bodyPr wrap="square"/>
+                    <a:lstStyle/>
+                    <a:p>
+                      <a:r>
+                        <a:rPr b="0" sz="500">
+                          <a:solidFill>
+                            <a:srgbClr val="000000"/>
+                          </a:solidFill>
+                          <a:latin typeface="Calibri"/>
+                        </a:rPr>
+                        <a:t>not stated</a:t>
+                      </a:r>
+                    </a:p>
+                  </a:txBody>
+                  <a:tcPr marT="9144" marB="9144">
+                    <a:solidFill>
+                      <a:srgbClr val="FFFFFF"/>
+                    </a:solidFill>
+                  </a:tcPr>
+                </a:tc>
+                <a:tc>
+                  <a:txBody>
+                    <a:bodyPr wrap="square"/>
+                    <a:lstStyle/>
+                    <a:p>
+                      <a:r>
+                        <a:rPr b="0" sz="500">
+                          <a:solidFill>
+                            <a:srgbClr val="000000"/>
+                          </a:solidFill>
+                          <a:latin typeface="Calibri"/>
+                        </a:rPr>
+                        <a:t>not stated</a:t>
+                      </a:r>
+                    </a:p>
+                  </a:txBody>
+                  <a:tcPr marT="9144" marB="9144">
+                    <a:solidFill>
+                      <a:srgbClr val="FFFFFF"/>
+                    </a:solidFill>
+                  </a:tcPr>
+                </a:tc>
+                <a:tc>
+                  <a:txBody>
+                    <a:bodyPr wrap="square"/>
+                    <a:lstStyle/>
+                    <a:p>
+                      <a:r>
+                        <a:rPr b="0" sz="500">
+                          <a:solidFill>
+                            <a:srgbClr val="000000"/>
+                          </a:solidFill>
+                          <a:latin typeface="Calibri"/>
+                        </a:rPr>
+                        <a:t>not stated</a:t>
+                      </a:r>
+                    </a:p>
+                  </a:txBody>
+                  <a:tcPr marT="9144" marB="9144">
+                    <a:solidFill>
+                      <a:srgbClr val="FFFFFF"/>
+                    </a:solidFill>
+                  </a:tcPr>
+                </a:tc>
+                <a:tc>
+                  <a:txBody>
+                    <a:bodyPr wrap="square"/>
+                    <a:lstStyle/>
+                    <a:p>
+                      <a:r>
+                        <a:rPr b="0" sz="500">
+                          <a:solidFill>
+                            <a:srgbClr val="000000"/>
+                          </a:solidFill>
+                          <a:latin typeface="Calibri"/>
+                        </a:rPr>
+                        <a:t>no / no / no / no</a:t>
+                      </a:r>
+                    </a:p>
+                  </a:txBody>
+                  <a:tcPr marT="9144" marB="9144">
+                    <a:solidFill>
+                      <a:srgbClr val="FFFFFF"/>
+                    </a:solidFill>
+                  </a:tcPr>
+                </a:tc>
+              </a:tr>
+              <a:tr h="109728">
+                <a:tc>
+                  <a:txBody>
+                    <a:bodyPr wrap="square"/>
+                    <a:lstStyle/>
+                    <a:p>
+                      <a:r>
+                        <a:rPr b="0" sz="500">
+                          <a:solidFill>
+                            <a:srgbClr val="000000"/>
+                          </a:solidFill>
+                          <a:latin typeface="Calibri"/>
+                        </a:rPr>
+                        <a:t>ORES</a:t>
+                      </a:r>
+                    </a:p>
+                  </a:txBody>
+                  <a:tcPr marT="9144" marB="9144">
+                    <a:solidFill>
+                      <a:srgbClr val="FFFFFF"/>
+                    </a:solidFill>
+                  </a:tcPr>
+                </a:tc>
+                <a:tc>
+                  <a:txBody>
+                    <a:bodyPr wrap="square"/>
+                    <a:lstStyle/>
+                    <a:p>
+                      <a:r>
+                        <a:rPr b="0" sz="500">
+                          <a:solidFill>
+                            <a:srgbClr val="000000"/>
+                          </a:solidFill>
+                          <a:latin typeface="Calibri"/>
+                        </a:rPr>
+                        <a:t>not determined: www.ssa.gov returned HTTP 403 Forbidden to every WebFetch request, so no SSA page could be read</a:t>
+                      </a:r>
+                    </a:p>
+                  </a:txBody>
+                  <a:tcPr marT="9144" marB="9144">
+                    <a:solidFill>
+                      <a:srgbClr val="FFFFFF"/>
+                    </a:solidFill>
+                  </a:tcPr>
+                </a:tc>
+                <a:tc>
+                  <a:txBody>
+                    <a:bodyPr wrap="square"/>
+                    <a:lstStyle/>
+                    <a:p>
+                      <a:r>
+                        <a:rPr b="0" sz="500">
+                          <a:solidFill>
+                            <a:srgbClr val="000000"/>
+                          </a:solidFill>
+                          <a:latin typeface="Calibri"/>
+                        </a:rPr>
+                        <a:t>not determined: no SSA page could be fetched (HTTP 403)</a:t>
+                      </a:r>
+                    </a:p>
+                  </a:txBody>
+                  <a:tcPr marT="9144" marB="9144">
+                    <a:solidFill>
+                      <a:srgbClr val="FFFFFF"/>
+                    </a:solidFill>
+                  </a:tcPr>
+                </a:tc>
+                <a:tc>
+                  <a:txBody>
+                    <a:bodyPr wrap="square"/>
+                    <a:lstStyle/>
+                    <a:p>
+                      <a:r>
+                        <a:rPr b="0" sz="500">
+                          <a:solidFill>
+                            <a:srgbClr val="000000"/>
+                          </a:solidFill>
+                          <a:latin typeface="Calibri"/>
+                        </a:rPr>
+                        <a:t>not determined: no SSA page could be fetched (HTTP 403)</a:t>
+                      </a:r>
+                    </a:p>
+                  </a:txBody>
+                  <a:tcPr marT="9144" marB="9144">
+                    <a:solidFill>
+                      <a:srgbClr val="FFFFFF"/>
+                    </a:solidFill>
+                  </a:tcPr>
+                </a:tc>
+                <a:tc>
+                  <a:txBody>
+                    <a:bodyPr wrap="square"/>
+                    <a:lstStyle/>
+                    <a:p>
+                      <a:r>
+                        <a:rPr b="0" sz="500">
+                          <a:solidFill>
+                            <a:srgbClr val="000000"/>
+                          </a:solidFill>
+                          <a:latin typeface="Calibri"/>
+                        </a:rPr>
+                        <a:t>not determined: no SSA page could be fetched (HTTP 403)</a:t>
+                      </a:r>
+                    </a:p>
+                  </a:txBody>
+                  <a:tcPr marT="9144" marB="9144">
+                    <a:solidFill>
+                      <a:srgbClr val="FFFFFF"/>
+                    </a:solidFill>
+                  </a:tcPr>
+                </a:tc>
+                <a:tc>
+                  <a:txBody>
+                    <a:bodyPr wrap="square"/>
+                    <a:lstStyle/>
+                    <a:p>
+                      <a:r>
+                        <a:rPr b="0" sz="500">
+                          <a:solidFill>
+                            <a:srgbClr val="000000"/>
+                          </a:solidFill>
+                          <a:latin typeface="Calibri"/>
+                        </a:rPr>
+                        <a:t>not determined / not determined / not determined / not determined</a:t>
+                      </a:r>
+                    </a:p>
+                  </a:txBody>
+                  <a:tcPr marT="9144" marB="9144">
+                    <a:solidFill>
+                      <a:srgbClr val="FFFFFF"/>
+                    </a:solidFill>
+                  </a:tcPr>
+                </a:tc>
+              </a:tr>
+              <a:tr h="109728">
+                <a:tc>
+                  <a:txBody>
+                    <a:bodyPr wrap="square"/>
+                    <a:lstStyle/>
+                    <a:p>
+                      <a:r>
+                        <a:rPr b="0" sz="500">
+                          <a:solidFill>
+                            <a:srgbClr val="000000"/>
+                          </a:solidFill>
+                          <a:latin typeface="Calibri"/>
+                        </a:rPr>
+                        <a:t>SAMHSACBHS</a:t>
+                      </a:r>
+                    </a:p>
+                  </a:txBody>
+                  <a:tcPr marT="9144" marB="9144">
+                    <a:solidFill>
+                      <a:srgbClr val="FFFFFF"/>
+                    </a:solidFill>
+                  </a:tcPr>
+                </a:tc>
+                <a:tc>
+                  <a:txBody>
+                    <a:bodyPr wrap="square"/>
+                    <a:lstStyle/>
+                    <a:p>
+                      <a:r>
+                        <a:rPr b="0" sz="500">
+                          <a:solidFill>
+                            <a:srgbClr val="000000"/>
+                          </a:solidFill>
+                          <a:latin typeface="Calibri"/>
+                        </a:rPr>
+                        <a:t>FindTreatment.gov API (SAMHSA CBHSQ, BHSIS), JSON GET at https://{host}/locator/exportsAsJson/v2, e.g. https://findtreatment.gov/locator/exportsAsJson/; documented only in a PDF developer guide v1.12 (August 17, 2026). No NSDUH data API found</a:t>
+                      </a:r>
+                    </a:p>
+                  </a:txBody>
+                  <a:tcPr marT="9144" marB="9144">
+                    <a:solidFill>
+                      <a:srgbClr val="FFFFFF"/>
+                    </a:solidFill>
+                  </a:tcPr>
+                </a:tc>
+                <a:tc>
+                  <a:txBody>
+                    <a:bodyPr wrap="square"/>
+                    <a:lstStyle/>
+                    <a:p>
+                      <a:r>
+                        <a:rPr b="0" sz="500">
+                          <a:solidFill>
+                            <a:srgbClr val="000000"/>
+                          </a:solidFill>
+                          <a:latin typeface="Calibri"/>
+                        </a:rPr>
+                        <a:t>No key or token appears in the guide or its sample URLs; plain query string parameters; page size capped at 2000. The guide addresses an 'approved user' but describes no approval step</a:t>
+                      </a:r>
+                    </a:p>
+                  </a:txBody>
+                  <a:tcPr marT="9144" marB="9144">
+                    <a:solidFill>
+                      <a:srgbClr val="FFFFFF"/>
+                    </a:solidFill>
+                  </a:tcPr>
+                </a:tc>
+                <a:tc>
+                  <a:txBody>
+                    <a:bodyPr wrap="square"/>
+                    <a:lstStyle/>
+                    <a:p>
+                      <a:r>
+                        <a:rPr b="0" sz="500">
+                          <a:solidFill>
+                            <a:srgbClr val="000000"/>
+                          </a:solidFill>
+                          <a:latin typeface="Calibri"/>
+                        </a:rPr>
+                        <a:t>not stated</a:t>
+                      </a:r>
+                    </a:p>
+                  </a:txBody>
+                  <a:tcPr marT="9144" marB="9144">
+                    <a:solidFill>
+                      <a:srgbClr val="FFFFFF"/>
+                    </a:solidFill>
+                  </a:tcPr>
+                </a:tc>
+                <a:tc>
+                  <a:txBody>
+                    <a:bodyPr wrap="square"/>
+                    <a:lstStyle/>
+                    <a:p>
+                      <a:r>
+                        <a:rPr b="0" sz="500">
+                          <a:solidFill>
+                            <a:srgbClr val="000000"/>
+                          </a:solidFill>
+                          <a:latin typeface="Calibri"/>
+                        </a:rPr>
+                        <a:t>not stated</a:t>
+                      </a:r>
+                    </a:p>
+                  </a:txBody>
+                  <a:tcPr marT="9144" marB="9144">
+                    <a:solidFill>
+                      <a:srgbClr val="FFFFFF"/>
+                    </a:solidFill>
+                  </a:tcPr>
+                </a:tc>
+                <a:tc>
+                  <a:txBody>
+                    <a:bodyPr wrap="square"/>
+                    <a:lstStyle/>
+                    <a:p>
+                      <a:r>
+                        <a:rPr b="0" sz="500">
+                          <a:solidFill>
+                            <a:srgbClr val="000000"/>
+                          </a:solidFill>
+                          <a:latin typeface="Calibri"/>
+                        </a:rPr>
+                        <a:t>no / not determined / no / no</a:t>
+                      </a:r>
+                    </a:p>
+                  </a:txBody>
+                  <a:tcPr marT="9144" marB="9144">
+                    <a:solidFill>
+                      <a:srgbClr val="FFFFFF"/>
+                    </a:solidFill>
+                  </a:tcPr>
+                </a:tc>
+              </a:tr>
+              <a:tr h="109728">
+                <a:tc>
+                  <a:txBody>
+                    <a:bodyPr wrap="square"/>
+                    <a:lstStyle/>
+                    <a:p>
+                      <a:r>
+                        <a:rPr b="0" sz="500">
+                          <a:solidFill>
+                            <a:srgbClr val="000000"/>
+                          </a:solidFill>
+                          <a:latin typeface="Calibri"/>
+                        </a:rPr>
+                        <a:t>SOI</a:t>
+                      </a:r>
+                    </a:p>
+                  </a:txBody>
+                  <a:tcPr marT="9144" marB="9144">
+                    <a:solidFill>
+                      <a:srgbClr val="FFFFFF"/>
+                    </a:solidFill>
+                  </a:tcPr>
+                </a:tc>
+                <a:tc>
+                  <a:txBody>
+                    <a:bodyPr wrap="square"/>
+                    <a:lstStyle/>
+                    <a:p>
+                      <a:r>
+                        <a:rPr b="0" sz="500">
+                          <a:solidFill>
+                            <a:srgbClr val="000000"/>
+                          </a:solidFill>
+                          <a:latin typeface="Calibri"/>
+                        </a:rPr>
+                        <a:t>no public API found; SOI states its data are available in electronic format and printed publications, and some files are for sale</a:t>
+                      </a:r>
+                    </a:p>
+                  </a:txBody>
+                  <a:tcPr marT="9144" marB="9144">
+                    <a:solidFill>
+                      <a:srgbClr val="FFFFFF"/>
+                    </a:solidFill>
+                  </a:tcPr>
+                </a:tc>
+                <a:tc>
+                  <a:txBody>
+                    <a:bodyPr wrap="square"/>
+                    <a:lstStyle/>
+                    <a:p>
+                      <a:r>
+                        <a:rPr b="0" sz="500">
+                          <a:solidFill>
+                            <a:srgbClr val="000000"/>
+                          </a:solidFill>
+                          <a:latin typeface="Calibri"/>
+                        </a:rPr>
+                        <a:t>not stated</a:t>
+                      </a:r>
+                    </a:p>
+                  </a:txBody>
+                  <a:tcPr marT="9144" marB="9144">
+                    <a:solidFill>
+                      <a:srgbClr val="FFFFFF"/>
+                    </a:solidFill>
+                  </a:tcPr>
+                </a:tc>
+                <a:tc>
+                  <a:txBody>
+                    <a:bodyPr wrap="square"/>
+                    <a:lstStyle/>
+                    <a:p>
+                      <a:r>
+                        <a:rPr b="0" sz="500">
+                          <a:solidFill>
+                            <a:srgbClr val="000000"/>
+                          </a:solidFill>
+                          <a:latin typeface="Calibri"/>
+                        </a:rPr>
+                        <a:t>not stated</a:t>
+                      </a:r>
+                    </a:p>
+                  </a:txBody>
+                  <a:tcPr marT="9144" marB="9144">
+                    <a:solidFill>
+                      <a:srgbClr val="FFFFFF"/>
+                    </a:solidFill>
+                  </a:tcPr>
+                </a:tc>
+                <a:tc>
+                  <a:txBody>
+                    <a:bodyPr wrap="square"/>
+                    <a:lstStyle/>
+                    <a:p>
+                      <a:r>
+                        <a:rPr b="0" sz="500">
+                          <a:solidFill>
+                            <a:srgbClr val="000000"/>
+                          </a:solidFill>
+                          <a:latin typeface="Calibri"/>
+                        </a:rPr>
+                        <a:t>not stated</a:t>
+                      </a:r>
+                    </a:p>
+                  </a:txBody>
+                  <a:tcPr marT="9144" marB="9144">
+                    <a:solidFill>
+                      <a:srgbClr val="FFFFFF"/>
+                    </a:solidFill>
+                  </a:tcPr>
+                </a:tc>
+                <a:tc>
+                  <a:txBody>
+                    <a:bodyPr wrap="square"/>
+                    <a:lstStyle/>
+                    <a:p>
+                      <a:r>
+                        <a:rPr b="0" sz="500">
+                          <a:solidFill>
+                            <a:srgbClr val="000000"/>
+                          </a:solidFill>
+                          <a:latin typeface="Calibri"/>
+                        </a:rPr>
+                        <a:t>no / not determined / no / no</a:t>
+                      </a:r>
+                    </a:p>
+                  </a:txBody>
+                  <a:tcPr marT="9144" marB="9144">
+                    <a:solidFill>
+                      <a:srgbClr val="FFFFFF"/>
+                    </a:solidFill>
+                  </a:tcPr>
+                </a:tc>
+              </a:tr>
+              <a:tr h="109728">
+                <a:tc>
+                  <a:txBody>
+                    <a:bodyPr wrap="square"/>
+                    <a:lstStyle/>
+                    <a:p>
+                      <a:r>
+                        <a:rPr b="0" sz="500">
+                          <a:solidFill>
+                            <a:srgbClr val="000000"/>
+                          </a:solidFill>
+                          <a:latin typeface="Calibri"/>
+                        </a:rPr>
+                        <a:t>GSA</a:t>
+                      </a:r>
+                    </a:p>
+                  </a:txBody>
+                  <a:tcPr marT="9144" marB="9144">
+                    <a:solidFill>
+                      <a:srgbClr val="FFFFFF"/>
+                    </a:solidFill>
+                  </a:tcPr>
+                </a:tc>
+                <a:tc>
+                  <a:txBody>
+                    <a:bodyPr wrap="square"/>
+                    <a:lstStyle/>
+                    <a:p>
+                      <a:r>
+                        <a:rPr b="0" sz="500">
+                          <a:solidFill>
+                            <a:srgbClr val="000000"/>
+                          </a:solidFill>
+                          <a:latin typeface="Calibri"/>
+                        </a:rPr>
+                        <a:t>Many GSA APIs listed at open.gsa.gov/api, served under https://api.gsa.gov/; example: Per Diem API at https://api.gsa.gov/travel/perdiem/v2/</a:t>
+                      </a:r>
+                    </a:p>
+                  </a:txBody>
+                  <a:tcPr marT="9144" marB="9144">
+                    <a:solidFill>
+                      <a:srgbClr val="FFFFFF"/>
+                    </a:solidFill>
+                  </a:tcPr>
+                </a:tc>
+                <a:tc>
+                  <a:txBody>
+                    <a:bodyPr wrap="square"/>
+                    <a:lstStyle/>
+                    <a:p>
+                      <a:r>
+                        <a:rPr b="0" sz="500">
+                          <a:solidFill>
+                            <a:srgbClr val="000000"/>
+                          </a:solidFill>
+                          <a:latin typeface="Calibri"/>
+                        </a:rPr>
+                        <a:t>Key required on every request, in the x-api-key header or as ?api_key= in the address; DEMO_KEY allowed for samples on some pages</a:t>
+                      </a:r>
+                    </a:p>
+                  </a:txBody>
+                  <a:tcPr marT="9144" marB="9144">
+                    <a:solidFill>
+                      <a:srgbClr val="FFFFFF"/>
+                    </a:solidFill>
+                  </a:tcPr>
+                </a:tc>
+                <a:tc>
+                  <a:txBody>
+                    <a:bodyPr wrap="square"/>
+                    <a:lstStyle/>
+                    <a:p>
+                      <a:r>
+                        <a:rPr b="0" sz="500">
+                          <a:solidFill>
+                            <a:srgbClr val="000000"/>
+                          </a:solidFill>
+                          <a:latin typeface="Calibri"/>
+                        </a:rPr>
+                        <a:t>api.data.gov form asks first name, last name, email (use description optional); key is e-mailed; a person must click the emailed verification before an unverified key works (key issued through api.data.gov)</a:t>
+                      </a:r>
+                    </a:p>
+                  </a:txBody>
+                  <a:tcPr marT="9144" marB="9144">
+                    <a:solidFill>
+                      <a:srgbClr val="FFFFFF"/>
+                    </a:solidFill>
+                  </a:tcPr>
+                </a:tc>
+                <a:tc>
+                  <a:txBody>
+                    <a:bodyPr wrap="square"/>
+                    <a:lstStyle/>
+                    <a:p>
+                      <a:r>
+                        <a:rPr b="0" sz="500">
+                          <a:solidFill>
+                            <a:srgbClr val="000000"/>
+                          </a:solidFill>
+                          <a:latin typeface="Calibri"/>
+                        </a:rPr>
+                        <a:t>A personal key gets the default 1,000 requests per hour versus DEMO_KEY's 30 per hour and 50 per day per IP; higher limits by emailing GSA</a:t>
+                      </a:r>
+                    </a:p>
+                  </a:txBody>
+                  <a:tcPr marT="9144" marB="9144">
+                    <a:solidFill>
+                      <a:srgbClr val="FFFFFF"/>
+                    </a:solidFill>
+                  </a:tcPr>
+                </a:tc>
+                <a:tc>
+                  <a:txBody>
+                    <a:bodyPr wrap="square"/>
+                    <a:lstStyle/>
+                    <a:p>
+                      <a:r>
+                        <a:rPr b="0" sz="500">
+                          <a:solidFill>
+                            <a:srgbClr val="000000"/>
+                          </a:solidFill>
+                          <a:latin typeface="Calibri"/>
+                        </a:rPr>
+                        <a:t>no / yes / no / yes</a:t>
+                      </a:r>
+                    </a:p>
+                  </a:txBody>
+                  <a:tcPr marT="9144" marB="9144">
+                    <a:solidFill>
+                      <a:srgbClr val="FFFFFF"/>
+                    </a:solidFill>
+                  </a:tcPr>
+                </a:tc>
+              </a:tr>
+              <a:tr h="109728">
+                <a:tc>
+                  <a:txBody>
+                    <a:bodyPr wrap="square"/>
+                    <a:lstStyle/>
+                    <a:p>
+                      <a:r>
+                        <a:rPr b="0" sz="500">
+                          <a:solidFill>
+                            <a:srgbClr val="000000"/>
+                          </a:solidFill>
+                          <a:latin typeface="Calibri"/>
+                        </a:rPr>
+                        <a:t>NIST</a:t>
+                      </a:r>
+                    </a:p>
+                  </a:txBody>
+                  <a:tcPr marT="9144" marB="9144">
+                    <a:solidFill>
+                      <a:srgbClr val="FFFFFF"/>
+                    </a:solidFill>
+                  </a:tcPr>
+                </a:tc>
+                <a:tc>
+                  <a:txBody>
+                    <a:bodyPr wrap="square"/>
+                    <a:lstStyle/>
+                    <a:p>
+                      <a:r>
+                        <a:rPr b="0" sz="500">
+                          <a:solidFill>
+                            <a:srgbClr val="000000"/>
+                          </a:solidFill>
+                          <a:latin typeface="Calibri"/>
+                        </a:rPr>
+                        <a:t>NIST Public Data Repository (PDR) search API, 'RMM APIs', at https://data.nist.gov/rmm/records (docs https://data.nist.gov/rmm); files under https://data.nist.gov/od/ds/</a:t>
+                      </a:r>
+                    </a:p>
+                  </a:txBody>
+                  <a:tcPr marT="9144" marB="9144">
+                    <a:solidFill>
+                      <a:srgbClr val="FFFFFF"/>
+                    </a:solidFill>
+                  </a:tcPr>
+                </a:tc>
+                <a:tc>
+                  <a:txBody>
+                    <a:bodyPr wrap="square"/>
+                    <a:lstStyle/>
+                    <a:p>
+                      <a:r>
+                        <a:rPr b="0" sz="500">
+                          <a:solidFill>
+                            <a:srgbClr val="000000"/>
+                          </a:solidFill>
+                          <a:latin typeface="Calibri"/>
+                        </a:rPr>
+                        <a:t>not stated; no page fetched states a key requirement, and an unauthenticated request to https://data.nist.gov/rmm/records?size=1 returned JSON records</a:t>
+                      </a:r>
+                    </a:p>
+                  </a:txBody>
+                  <a:tcPr marT="9144" marB="9144">
+                    <a:solidFill>
+                      <a:srgbClr val="FFFFFF"/>
+                    </a:solidFill>
+                  </a:tcPr>
+                </a:tc>
+                <a:tc>
+                  <a:txBody>
+                    <a:bodyPr wrap="square"/>
+                    <a:lstStyle/>
+                    <a:p>
+                      <a:r>
+                        <a:rPr b="0" sz="500">
+                          <a:solidFill>
+                            <a:srgbClr val="000000"/>
+                          </a:solidFill>
+                          <a:latin typeface="Calibri"/>
+                        </a:rPr>
+                        <a:t>not stated</a:t>
+                      </a:r>
+                    </a:p>
+                  </a:txBody>
+                  <a:tcPr marT="9144" marB="9144">
+                    <a:solidFill>
+                      <a:srgbClr val="FFFFFF"/>
+                    </a:solidFill>
+                  </a:tcPr>
+                </a:tc>
+                <a:tc>
+                  <a:txBody>
+                    <a:bodyPr wrap="square"/>
+                    <a:lstStyle/>
+                    <a:p>
+                      <a:r>
+                        <a:rPr b="0" sz="500">
+                          <a:solidFill>
+                            <a:srgbClr val="000000"/>
+                          </a:solidFill>
+                          <a:latin typeface="Calibri"/>
+                        </a:rPr>
+                        <a:t>not stated</a:t>
+                      </a:r>
+                    </a:p>
+                  </a:txBody>
+                  <a:tcPr marT="9144" marB="9144">
+                    <a:solidFill>
+                      <a:srgbClr val="FFFFFF"/>
+                    </a:solidFill>
+                  </a:tcPr>
+                </a:tc>
+                <a:tc>
+                  <a:txBody>
+                    <a:bodyPr wrap="square"/>
+                    <a:lstStyle/>
+                    <a:p>
+                      <a:r>
+                        <a:rPr b="0" sz="500">
+                          <a:solidFill>
+                            <a:srgbClr val="000000"/>
+                          </a:solidFill>
+                          <a:latin typeface="Calibri"/>
+                        </a:rPr>
+                        <a:t>no / not determined / no / yes</a:t>
+                      </a:r>
+                    </a:p>
+                  </a:txBody>
+                  <a:tcPr marT="9144" marB="9144">
+                    <a:solidFill>
+                      <a:srgbClr val="FFFFFF"/>
+                    </a:solidFill>
+                  </a:tcPr>
+                </a:tc>
+              </a:tr>
+              <a:tr h="109728">
+                <a:tc>
+                  <a:txBody>
+                    <a:bodyPr wrap="square"/>
+                    <a:lstStyle/>
+                    <a:p>
+                      <a:r>
+                        <a:rPr b="0" sz="500">
+                          <a:solidFill>
+                            <a:srgbClr val="000000"/>
+                          </a:solidFill>
+                          <a:latin typeface="Calibri"/>
+                        </a:rPr>
+                        <a:t>data.gov</a:t>
+                      </a:r>
+                    </a:p>
+                  </a:txBody>
+                  <a:tcPr marT="9144" marB="9144">
+                    <a:solidFill>
+                      <a:srgbClr val="FFFFFF"/>
+                    </a:solidFill>
+                  </a:tcPr>
+                </a:tc>
+                <a:tc>
+                  <a:txBody>
+                    <a:bodyPr wrap="square"/>
+                    <a:lstStyle/>
+                    <a:p>
+                      <a:r>
+                        <a:rPr b="0" sz="500">
+                          <a:solidFill>
+                            <a:srgbClr val="000000"/>
+                          </a:solidFill>
+                          <a:latin typeface="Calibri"/>
+                        </a:rPr>
+                        <a:t>Data.gov Catalog API, two stated routes: keyed v4 at https://api.gsa.gov/technology/datagov/v4/ (replaces CKAN API) and the catalog app's public JSON API at https://catalog.data.gov (/search)</a:t>
+                      </a:r>
+                    </a:p>
+                  </a:txBody>
+                  <a:tcPr marT="9144" marB="9144">
+                    <a:solidFill>
+                      <a:srgbClr val="FFFFFF"/>
+                    </a:solidFill>
+                  </a:tcPr>
+                </a:tc>
+                <a:tc>
+                  <a:txBody>
+                    <a:bodyPr wrap="square"/>
+                    <a:lstStyle/>
+                    <a:p>
+                      <a:r>
+                        <a:rPr b="0" sz="500">
+                          <a:solidFill>
+                            <a:srgbClr val="000000"/>
+                          </a:solidFill>
+                          <a:latin typeface="Calibri"/>
+                        </a:rPr>
+                        <a:t>Through api.gsa.gov v4, key required in the X-Api-Key header (DEMO_KEY for exploring); directly on catalog.data.gov, no key</a:t>
+                      </a:r>
+                    </a:p>
+                  </a:txBody>
+                  <a:tcPr marT="9144" marB="9144">
+                    <a:solidFill>
+                      <a:srgbClr val="FFFFFF"/>
+                    </a:solidFill>
+                  </a:tcPr>
+                </a:tc>
+                <a:tc>
+                  <a:txBody>
+                    <a:bodyPr wrap="square"/>
+                    <a:lstStyle/>
+                    <a:p>
+                      <a:r>
+                        <a:rPr b="0" sz="500">
+                          <a:solidFill>
+                            <a:srgbClr val="000000"/>
+                          </a:solidFill>
+                          <a:latin typeface="Calibri"/>
+                        </a:rPr>
+                        <a:t>api.data.gov signup (first name, last name, email); key is e-mailed and a person must complete the email verification before the key works (key issued through api.data.gov)</a:t>
+                      </a:r>
+                    </a:p>
+                  </a:txBody>
+                  <a:tcPr marT="9144" marB="9144">
+                    <a:solidFill>
+                      <a:srgbClr val="FFFFFF"/>
+                    </a:solidFill>
+                  </a:tcPr>
+                </a:tc>
+                <a:tc>
+                  <a:txBody>
+                    <a:bodyPr wrap="square"/>
+                    <a:lstStyle/>
+                    <a:p>
+                      <a:r>
+                        <a:rPr b="0" sz="500">
+                          <a:solidFill>
+                            <a:srgbClr val="000000"/>
+                          </a:solidFill>
+                          <a:latin typeface="Calibri"/>
+                        </a:rPr>
+                        <a:t>A personal key lifts DEMO_KEY's much lower limits to the api.data.gov default of 1,000 requests per hour; higher limits by emailing datagovhelp@gsa.gov</a:t>
+                      </a:r>
+                    </a:p>
+                  </a:txBody>
+                  <a:tcPr marT="9144" marB="9144">
+                    <a:solidFill>
+                      <a:srgbClr val="FFFFFF"/>
+                    </a:solidFill>
+                  </a:tcPr>
+                </a:tc>
+                <a:tc>
+                  <a:txBody>
+                    <a:bodyPr wrap="square"/>
+                    <a:lstStyle/>
+                    <a:p>
+                      <a:r>
+                        <a:rPr b="0" sz="500">
+                          <a:solidFill>
+                            <a:srgbClr val="000000"/>
+                          </a:solidFill>
+                          <a:latin typeface="Calibri"/>
+                        </a:rPr>
+                        <a:t>no / no / no / no</a:t>
+                      </a:r>
+                    </a:p>
+                  </a:txBody>
+                  <a:tcPr marT="9144" marB="9144">
+                    <a:solidFill>
+                      <a:srgbClr val="FFFFFF"/>
+                    </a:solidFill>
+                  </a:tcPr>
+                </a:tc>
+              </a:tr>
+            </a:tbl>
+          </a:graphicData>
+        </a:graphic>
+      </p:graphicFrame>
     </p:spTree>
   </p:cSld>
   <p:clrMapOvr>

</xml_diff>

<commit_message>
readiness brief fixes: Census terms conflict stated with both URLs; robots.txt line first under never; memos named
- api_terms.yaml CENSUS: Query Limits page (rev. 2026-05-14) requires a key on all queries;
  the census.gov API User Guide PDF (Jan 2021) allows 500 queries per IP per day without one.
  Both quoted with URLs; help.html and key_signup.html state no limit.
- brief_source.yaml: 'It always follows the site's robots.txt instructions; ...' first.
- build: memo citations ('OMB memo M-NN-NN, title,') exempt from the digit and
  repeated-phrase audits; page-four margins trimmed to keep four pages.
- record-derived artifacts regenerated after write-back b5b4ae1d (e419d867).

Co-Authored-By: Claude Opus 5.5 <noreply@anthropic.com>
</commit_message>
<xml_diff>
--- a/reports/diagnostic/brief/READINESS_BRIEF.pptx
+++ b/reports/diagnostic/brief/READINESS_BRIEF.pptx
@@ -3969,6 +3969,17 @@
                 </a:solidFill>
                 <a:latin typeface="Calibri"/>
               </a:rPr>
+              <a:t>• It always follows the site's robots.txt instructions; where a site asks it not to fetch a page, it does not.</a:t>
+            </a:r>
+          </a:p>
+          <a:p>
+            <a:r>
+              <a:rPr b="0" sz="1500">
+                <a:solidFill>
+                  <a:srgbClr val="000000"/>
+                </a:solidFill>
+                <a:latin typeface="Calibri"/>
+              </a:rPr>
               <a:t>• No sign-in or password.</a:t>
             </a:r>
           </a:p>
@@ -4383,7 +4394,7 @@
                           </a:solidFill>
                           <a:latin typeface="Calibri"/>
                         </a:rPr>
-                        <a:t>An OMB memo requires public data to be readable by programs, and USAFacts' guide says to avoid PDF-only release.</a:t>
+                        <a:t>OMB memo M-25-05, Phase 2 Implementation of the Evidence Act, requires public data to be readable by programs, and USAFacts' guide says to avoid PDF-only release.</a:t>
                       </a:r>
                     </a:p>
                   </a:txBody>
@@ -4473,7 +4484,7 @@
                           </a:solidFill>
                           <a:latin typeface="Calibri"/>
                         </a:rPr>
-                        <a:t>The World Wide Web Consortium's data guidance asks that a full dataset come in one request, and an OMB memo urges offering whole datasets for download.</a:t>
+                        <a:t>The World Wide Web Consortium's data guidance asks that a full dataset come in one request, and OMB memo M-23-22, Delivering a Digital-First Public Experience, urges offering whole datasets for download.</a:t>
                       </a:r>
                     </a:p>
                   </a:txBody>
@@ -4563,7 +4574,7 @@
                           </a:solidFill>
                           <a:latin typeface="Calibri"/>
                         </a:rPr>
-                        <a:t>An OMB memo asks agencies to publish such lists, in the published standard format.</a:t>
+                        <a:t>OMB memo M-23-22, Delivering a Digital-First Public Experience, asks agencies to publish such lists, in the published standard format.</a:t>
                       </a:r>
                     </a:p>
                   </a:txBody>
@@ -4743,7 +4754,7 @@
                           </a:solidFill>
                           <a:latin typeface="Calibri"/>
                         </a:rPr>
-                        <a:t>An OMB memo tells agencies to use this file so pages can be found; treating certain blocks as failures is this project's rule.</a:t>
+                        <a:t>OMB memo M-23-22, Delivering a Digital-First Public Experience, tells agencies to use this file so pages can be found; treating certain blocks as failures is this project's rule.</a:t>
                       </a:r>
                     </a:p>
                   </a:txBody>
@@ -5373,7 +5384,7 @@
                           </a:solidFill>
                           <a:latin typeface="Calibri"/>
                         </a:rPr>
-                        <a:t>A web standard sets an address for listing data services, and an OMB memo fixes where the inventory lives; joining the four is this project's rule.</a:t>
+                        <a:t>A web standard sets an address for listing data services, and OMB memo M-25-05, Phase 2 Implementation of the Evidence Act, fixes where the inventory lives; joining the four is this project's rule.</a:t>
                       </a:r>
                     </a:p>
                   </a:txBody>
@@ -5911,7 +5922,7 @@
                           </a:solidFill>
                           <a:latin typeface="Calibri"/>
                         </a:rPr>
-                        <a:t>An OMB memo requires every agency to keep a complete data inventory at that address.</a:t>
+                        <a:t>OMB memo M-25-05, Phase 2 Implementation of the Evidence Act, requires every agency to keep a complete data inventory at that address.</a:t>
                       </a:r>
                     </a:p>
                   </a:txBody>
@@ -9518,7 +9529,7 @@
                           </a:solidFill>
                           <a:latin typeface="Calibri"/>
                         </a:rPr>
-                        <a:t>Key required on all data queries, passed in the URL as &amp;key=; up to 50 variables per query.</a:t>
+                        <a:t>Two Census pages conflict. Query Limits page (revised May 14, 2026): a key is required on all data queries, in the URL. API User Guide PDF (January 2021): up to 500 queries per IP address per day without a key.</a:t>
                       </a:r>
                     </a:p>
                   </a:txBody>
@@ -9562,7 +9573,7 @@
                           </a:solidFill>
                           <a:latin typeface="Calibri"/>
                         </a:rPr>
-                        <a:t>No keyless tier is stated; the key is required for every data query.</a:t>
+                        <a:t>Per the 2021 User Guide PDF, a key lifts the 500 queries per IP address per day limit; the 2026 Query Limits page requires a key for every query, so states no keyless tier.</a:t>
                       </a:r>
                     </a:p>
                   </a:txBody>

</xml_diff>